<commit_message>
Improved tree building logic, updated table migration order, added column handling, and optimized query sorting.
</commit_message>
<xml_diff>
--- a/docs/FirstFaults_Presentatie_NL.pptx
+++ b/docs/FirstFaults_Presentatie_NL.pptx
@@ -4,19 +4,22 @@
   <p:sldMasterIdLst>
     <p:sldMasterId id="2147483648" r:id="rId1"/>
   </p:sldMasterIdLst>
+  <p:notesMasterIdLst>
+    <p:notesMasterId r:id="rId12"/>
+  </p:notesMasterIdLst>
   <p:sldIdLst>
-    <p:sldId id="256" r:id="rId7"/>
-    <p:sldId id="257" r:id="rId8"/>
-    <p:sldId id="258" r:id="rId9"/>
-    <p:sldId id="259" r:id="rId10"/>
-    <p:sldId id="260" r:id="rId11"/>
-    <p:sldId id="261" r:id="rId12"/>
-    <p:sldId id="262" r:id="rId13"/>
-    <p:sldId id="263" r:id="rId14"/>
-    <p:sldId id="264" r:id="rId15"/>
-    <p:sldId id="265" r:id="rId16"/>
+    <p:sldId id="256" r:id="rId2"/>
+    <p:sldId id="257" r:id="rId3"/>
+    <p:sldId id="258" r:id="rId4"/>
+    <p:sldId id="259" r:id="rId5"/>
+    <p:sldId id="260" r:id="rId6"/>
+    <p:sldId id="261" r:id="rId7"/>
+    <p:sldId id="262" r:id="rId8"/>
+    <p:sldId id="263" r:id="rId9"/>
+    <p:sldId id="264" r:id="rId10"/>
+    <p:sldId id="265" r:id="rId11"/>
   </p:sldIdLst>
-  <p:sldSz cx="12188952" cy="6858000" type="screen4x3"/>
+  <p:sldSz cx="12188825" cy="6858000"/>
   <p:notesSz cx="6858000" cy="9144000"/>
   <p:defaultTextStyle>
     <a:defPPr>
@@ -113,7 +116,457 @@
       </a:defRPr>
     </a:lvl9pPr>
   </p:defaultTextStyle>
+  <p:extLst>
+    <p:ext uri="{EFAFB233-063F-42B5-8137-9DF3F51BA10A}">
+      <p15:sldGuideLst xmlns:p15="http://schemas.microsoft.com/office/powerpoint/2012/main">
+        <p15:guide id="1" orient="horz" pos="2160">
+          <p15:clr>
+            <a:srgbClr val="A4A3A4"/>
+          </p15:clr>
+        </p15:guide>
+        <p15:guide id="2" pos="2880">
+          <p15:clr>
+            <a:srgbClr val="A4A3A4"/>
+          </p15:clr>
+        </p15:guide>
+      </p15:sldGuideLst>
+    </p:ext>
+  </p:extLst>
 </p:presentation>
+</file>
+
+<file path=ppt/notesMasters/notesMaster1.xml><?xml version="1.0" encoding="utf-8"?>
+<p:notesMaster xmlns:a="http://schemas.openxmlformats.org/drawingml/2006/main" xmlns:r="http://schemas.openxmlformats.org/officeDocument/2006/relationships" xmlns:p="http://schemas.openxmlformats.org/presentationml/2006/main">
+  <p:cSld>
+    <p:bg>
+      <p:bgRef idx="1001">
+        <a:schemeClr val="bg1"/>
+      </p:bgRef>
+    </p:bg>
+    <p:spTree>
+      <p:nvGrpSpPr>
+        <p:cNvPr id="1" name=""/>
+        <p:cNvGrpSpPr/>
+        <p:nvPr/>
+      </p:nvGrpSpPr>
+      <p:grpSpPr>
+        <a:xfrm>
+          <a:off x="0" y="0"/>
+          <a:ext cx="0" cy="0"/>
+          <a:chOff x="0" y="0"/>
+          <a:chExt cx="0" cy="0"/>
+        </a:xfrm>
+      </p:grpSpPr>
+      <p:sp>
+        <p:nvSpPr>
+          <p:cNvPr id="2" name="Tijdelijke aanduiding voor koptekst 1"/>
+          <p:cNvSpPr>
+            <a:spLocks noGrp="1"/>
+          </p:cNvSpPr>
+          <p:nvPr>
+            <p:ph type="hdr" sz="quarter"/>
+          </p:nvPr>
+        </p:nvSpPr>
+        <p:spPr>
+          <a:xfrm>
+            <a:off x="0" y="0"/>
+            <a:ext cx="2971800" cy="458788"/>
+          </a:xfrm>
+          <a:prstGeom prst="rect">
+            <a:avLst/>
+          </a:prstGeom>
+        </p:spPr>
+        <p:txBody>
+          <a:bodyPr vert="horz" lIns="91440" tIns="45720" rIns="91440" bIns="45720" rtlCol="0"/>
+          <a:lstStyle>
+            <a:lvl1pPr algn="l">
+              <a:defRPr sz="1200"/>
+            </a:lvl1pPr>
+          </a:lstStyle>
+          <a:p>
+            <a:endParaRPr lang="nl-BE"/>
+          </a:p>
+        </p:txBody>
+      </p:sp>
+      <p:sp>
+        <p:nvSpPr>
+          <p:cNvPr id="3" name="Tijdelijke aanduiding voor datum 2"/>
+          <p:cNvSpPr>
+            <a:spLocks noGrp="1"/>
+          </p:cNvSpPr>
+          <p:nvPr>
+            <p:ph type="dt" idx="1"/>
+          </p:nvPr>
+        </p:nvSpPr>
+        <p:spPr>
+          <a:xfrm>
+            <a:off x="3884613" y="0"/>
+            <a:ext cx="2971800" cy="458788"/>
+          </a:xfrm>
+          <a:prstGeom prst="rect">
+            <a:avLst/>
+          </a:prstGeom>
+        </p:spPr>
+        <p:txBody>
+          <a:bodyPr vert="horz" lIns="91440" tIns="45720" rIns="91440" bIns="45720" rtlCol="0"/>
+          <a:lstStyle>
+            <a:lvl1pPr algn="r">
+              <a:defRPr sz="1200"/>
+            </a:lvl1pPr>
+          </a:lstStyle>
+          <a:p>
+            <a:fld id="{223B7DE9-F5B2-5244-946E-912611C073BB}" type="datetimeFigureOut">
+              <a:rPr lang="nl-BE" smtClean="0"/>
+              <a:t>30/05/2026</a:t>
+            </a:fld>
+            <a:endParaRPr lang="nl-BE"/>
+          </a:p>
+        </p:txBody>
+      </p:sp>
+      <p:sp>
+        <p:nvSpPr>
+          <p:cNvPr id="4" name="Tijdelijke aanduiding voor dia-afbeelding 3"/>
+          <p:cNvSpPr>
+            <a:spLocks noGrp="1" noRot="1" noChangeAspect="1"/>
+          </p:cNvSpPr>
+          <p:nvPr>
+            <p:ph type="sldImg" idx="2"/>
+          </p:nvPr>
+        </p:nvSpPr>
+        <p:spPr>
+          <a:xfrm>
+            <a:off x="685800" y="1143000"/>
+            <a:ext cx="5486400" cy="3086100"/>
+          </a:xfrm>
+          <a:prstGeom prst="rect">
+            <a:avLst/>
+          </a:prstGeom>
+          <a:noFill/>
+          <a:ln w="12700">
+            <a:solidFill>
+              <a:prstClr val="black"/>
+            </a:solidFill>
+          </a:ln>
+        </p:spPr>
+        <p:txBody>
+          <a:bodyPr vert="horz" lIns="91440" tIns="45720" rIns="91440" bIns="45720" rtlCol="0" anchor="ctr"/>
+          <a:lstStyle/>
+          <a:p>
+            <a:endParaRPr lang="nl-BE"/>
+          </a:p>
+        </p:txBody>
+      </p:sp>
+      <p:sp>
+        <p:nvSpPr>
+          <p:cNvPr id="5" name="Tijdelijke aanduiding voor notities 4"/>
+          <p:cNvSpPr>
+            <a:spLocks noGrp="1"/>
+          </p:cNvSpPr>
+          <p:nvPr>
+            <p:ph type="body" sz="quarter" idx="3"/>
+          </p:nvPr>
+        </p:nvSpPr>
+        <p:spPr>
+          <a:xfrm>
+            <a:off x="685800" y="4400550"/>
+            <a:ext cx="5486400" cy="3600450"/>
+          </a:xfrm>
+          <a:prstGeom prst="rect">
+            <a:avLst/>
+          </a:prstGeom>
+        </p:spPr>
+        <p:txBody>
+          <a:bodyPr vert="horz" lIns="91440" tIns="45720" rIns="91440" bIns="45720" rtlCol="0"/>
+          <a:lstStyle/>
+          <a:p>
+            <a:pPr lvl="0"/>
+            <a:r>
+              <a:rPr lang="nl-NL"/>
+              <a:t>Klikken om de tekststijl van het model te bewerken</a:t>
+            </a:r>
+          </a:p>
+          <a:p>
+            <a:pPr lvl="1"/>
+            <a:r>
+              <a:rPr lang="nl-NL"/>
+              <a:t>Tweede niveau</a:t>
+            </a:r>
+          </a:p>
+          <a:p>
+            <a:pPr lvl="2"/>
+            <a:r>
+              <a:rPr lang="nl-NL"/>
+              <a:t>Derde niveau</a:t>
+            </a:r>
+          </a:p>
+          <a:p>
+            <a:pPr lvl="3"/>
+            <a:r>
+              <a:rPr lang="nl-NL"/>
+              <a:t>Vierde niveau</a:t>
+            </a:r>
+          </a:p>
+          <a:p>
+            <a:pPr lvl="4"/>
+            <a:r>
+              <a:rPr lang="nl-NL"/>
+              <a:t>Vijfde niveau</a:t>
+            </a:r>
+            <a:endParaRPr lang="nl-BE"/>
+          </a:p>
+        </p:txBody>
+      </p:sp>
+      <p:sp>
+        <p:nvSpPr>
+          <p:cNvPr id="6" name="Tijdelijke aanduiding voor voettekst 5"/>
+          <p:cNvSpPr>
+            <a:spLocks noGrp="1"/>
+          </p:cNvSpPr>
+          <p:nvPr>
+            <p:ph type="ftr" sz="quarter" idx="4"/>
+          </p:nvPr>
+        </p:nvSpPr>
+        <p:spPr>
+          <a:xfrm>
+            <a:off x="0" y="8685213"/>
+            <a:ext cx="2971800" cy="458787"/>
+          </a:xfrm>
+          <a:prstGeom prst="rect">
+            <a:avLst/>
+          </a:prstGeom>
+        </p:spPr>
+        <p:txBody>
+          <a:bodyPr vert="horz" lIns="91440" tIns="45720" rIns="91440" bIns="45720" rtlCol="0" anchor="b"/>
+          <a:lstStyle>
+            <a:lvl1pPr algn="l">
+              <a:defRPr sz="1200"/>
+            </a:lvl1pPr>
+          </a:lstStyle>
+          <a:p>
+            <a:endParaRPr lang="nl-BE"/>
+          </a:p>
+        </p:txBody>
+      </p:sp>
+      <p:sp>
+        <p:nvSpPr>
+          <p:cNvPr id="7" name="Tijdelijke aanduiding voor dianummer 6"/>
+          <p:cNvSpPr>
+            <a:spLocks noGrp="1"/>
+          </p:cNvSpPr>
+          <p:nvPr>
+            <p:ph type="sldNum" sz="quarter" idx="5"/>
+          </p:nvPr>
+        </p:nvSpPr>
+        <p:spPr>
+          <a:xfrm>
+            <a:off x="3884613" y="8685213"/>
+            <a:ext cx="2971800" cy="458787"/>
+          </a:xfrm>
+          <a:prstGeom prst="rect">
+            <a:avLst/>
+          </a:prstGeom>
+        </p:spPr>
+        <p:txBody>
+          <a:bodyPr vert="horz" lIns="91440" tIns="45720" rIns="91440" bIns="45720" rtlCol="0" anchor="b"/>
+          <a:lstStyle>
+            <a:lvl1pPr algn="r">
+              <a:defRPr sz="1200"/>
+            </a:lvl1pPr>
+          </a:lstStyle>
+          <a:p>
+            <a:fld id="{8CBE09F5-4AE9-7A42-BE7A-80876203947F}" type="slidenum">
+              <a:rPr lang="nl-BE" smtClean="0"/>
+              <a:t>‹nr.›</a:t>
+            </a:fld>
+            <a:endParaRPr lang="nl-BE"/>
+          </a:p>
+        </p:txBody>
+      </p:sp>
+    </p:spTree>
+    <p:extLst>
+      <p:ext uri="{BB962C8B-B14F-4D97-AF65-F5344CB8AC3E}">
+        <p14:creationId xmlns:p14="http://schemas.microsoft.com/office/powerpoint/2010/main" val="4017575048"/>
+      </p:ext>
+    </p:extLst>
+  </p:cSld>
+  <p:clrMap bg1="lt1" tx1="dk1" bg2="lt2" tx2="dk2" accent1="accent1" accent2="accent2" accent3="accent3" accent4="accent4" accent5="accent5" accent6="accent6" hlink="hlink" folHlink="folHlink"/>
+  <p:notesStyle>
+    <a:lvl1pPr marL="0" algn="l" defTabSz="914400" rtl="0" eaLnBrk="1" latinLnBrk="0" hangingPunct="1">
+      <a:defRPr sz="1200" kern="1200">
+        <a:solidFill>
+          <a:schemeClr val="tx1"/>
+        </a:solidFill>
+        <a:latin typeface="+mn-lt"/>
+        <a:ea typeface="+mn-ea"/>
+        <a:cs typeface="+mn-cs"/>
+      </a:defRPr>
+    </a:lvl1pPr>
+    <a:lvl2pPr marL="457200" algn="l" defTabSz="914400" rtl="0" eaLnBrk="1" latinLnBrk="0" hangingPunct="1">
+      <a:defRPr sz="1200" kern="1200">
+        <a:solidFill>
+          <a:schemeClr val="tx1"/>
+        </a:solidFill>
+        <a:latin typeface="+mn-lt"/>
+        <a:ea typeface="+mn-ea"/>
+        <a:cs typeface="+mn-cs"/>
+      </a:defRPr>
+    </a:lvl2pPr>
+    <a:lvl3pPr marL="914400" algn="l" defTabSz="914400" rtl="0" eaLnBrk="1" latinLnBrk="0" hangingPunct="1">
+      <a:defRPr sz="1200" kern="1200">
+        <a:solidFill>
+          <a:schemeClr val="tx1"/>
+        </a:solidFill>
+        <a:latin typeface="+mn-lt"/>
+        <a:ea typeface="+mn-ea"/>
+        <a:cs typeface="+mn-cs"/>
+      </a:defRPr>
+    </a:lvl3pPr>
+    <a:lvl4pPr marL="1371600" algn="l" defTabSz="914400" rtl="0" eaLnBrk="1" latinLnBrk="0" hangingPunct="1">
+      <a:defRPr sz="1200" kern="1200">
+        <a:solidFill>
+          <a:schemeClr val="tx1"/>
+        </a:solidFill>
+        <a:latin typeface="+mn-lt"/>
+        <a:ea typeface="+mn-ea"/>
+        <a:cs typeface="+mn-cs"/>
+      </a:defRPr>
+    </a:lvl4pPr>
+    <a:lvl5pPr marL="1828800" algn="l" defTabSz="914400" rtl="0" eaLnBrk="1" latinLnBrk="0" hangingPunct="1">
+      <a:defRPr sz="1200" kern="1200">
+        <a:solidFill>
+          <a:schemeClr val="tx1"/>
+        </a:solidFill>
+        <a:latin typeface="+mn-lt"/>
+        <a:ea typeface="+mn-ea"/>
+        <a:cs typeface="+mn-cs"/>
+      </a:defRPr>
+    </a:lvl5pPr>
+    <a:lvl6pPr marL="2286000" algn="l" defTabSz="914400" rtl="0" eaLnBrk="1" latinLnBrk="0" hangingPunct="1">
+      <a:defRPr sz="1200" kern="1200">
+        <a:solidFill>
+          <a:schemeClr val="tx1"/>
+        </a:solidFill>
+        <a:latin typeface="+mn-lt"/>
+        <a:ea typeface="+mn-ea"/>
+        <a:cs typeface="+mn-cs"/>
+      </a:defRPr>
+    </a:lvl6pPr>
+    <a:lvl7pPr marL="2743200" algn="l" defTabSz="914400" rtl="0" eaLnBrk="1" latinLnBrk="0" hangingPunct="1">
+      <a:defRPr sz="1200" kern="1200">
+        <a:solidFill>
+          <a:schemeClr val="tx1"/>
+        </a:solidFill>
+        <a:latin typeface="+mn-lt"/>
+        <a:ea typeface="+mn-ea"/>
+        <a:cs typeface="+mn-cs"/>
+      </a:defRPr>
+    </a:lvl7pPr>
+    <a:lvl8pPr marL="3200400" algn="l" defTabSz="914400" rtl="0" eaLnBrk="1" latinLnBrk="0" hangingPunct="1">
+      <a:defRPr sz="1200" kern="1200">
+        <a:solidFill>
+          <a:schemeClr val="tx1"/>
+        </a:solidFill>
+        <a:latin typeface="+mn-lt"/>
+        <a:ea typeface="+mn-ea"/>
+        <a:cs typeface="+mn-cs"/>
+      </a:defRPr>
+    </a:lvl8pPr>
+    <a:lvl9pPr marL="3657600" algn="l" defTabSz="914400" rtl="0" eaLnBrk="1" latinLnBrk="0" hangingPunct="1">
+      <a:defRPr sz="1200" kern="1200">
+        <a:solidFill>
+          <a:schemeClr val="tx1"/>
+        </a:solidFill>
+        <a:latin typeface="+mn-lt"/>
+        <a:ea typeface="+mn-ea"/>
+        <a:cs typeface="+mn-cs"/>
+      </a:defRPr>
+    </a:lvl9pPr>
+  </p:notesStyle>
+</p:notesMaster>
+</file>
+
+<file path=ppt/notesSlides/notesSlide1.xml><?xml version="1.0" encoding="utf-8"?>
+<p:notes xmlns:a="http://schemas.openxmlformats.org/drawingml/2006/main" xmlns:r="http://schemas.openxmlformats.org/officeDocument/2006/relationships" xmlns:p="http://schemas.openxmlformats.org/presentationml/2006/main">
+  <p:cSld>
+    <p:spTree>
+      <p:nvGrpSpPr>
+        <p:cNvPr id="1" name=""/>
+        <p:cNvGrpSpPr/>
+        <p:nvPr/>
+      </p:nvGrpSpPr>
+      <p:grpSpPr>
+        <a:xfrm>
+          <a:off x="0" y="0"/>
+          <a:ext cx="0" cy="0"/>
+          <a:chOff x="0" y="0"/>
+          <a:chExt cx="0" cy="0"/>
+        </a:xfrm>
+      </p:grpSpPr>
+      <p:sp>
+        <p:nvSpPr>
+          <p:cNvPr id="2" name="Tijdelijke aanduiding voor dia-afbeelding 1"/>
+          <p:cNvSpPr>
+            <a:spLocks noGrp="1" noRot="1" noChangeAspect="1"/>
+          </p:cNvSpPr>
+          <p:nvPr>
+            <p:ph type="sldImg"/>
+          </p:nvPr>
+        </p:nvSpPr>
+        <p:spPr/>
+      </p:sp>
+      <p:sp>
+        <p:nvSpPr>
+          <p:cNvPr id="3" name="Tijdelijke aanduiding voor notities 2"/>
+          <p:cNvSpPr>
+            <a:spLocks noGrp="1"/>
+          </p:cNvSpPr>
+          <p:nvPr>
+            <p:ph type="body" idx="1"/>
+          </p:nvPr>
+        </p:nvSpPr>
+        <p:spPr/>
+        <p:txBody>
+          <a:bodyPr/>
+          <a:lstStyle/>
+          <a:p>
+            <a:endParaRPr lang="nl-BE" dirty="0"/>
+          </a:p>
+        </p:txBody>
+      </p:sp>
+      <p:sp>
+        <p:nvSpPr>
+          <p:cNvPr id="4" name="Tijdelijke aanduiding voor dianummer 3"/>
+          <p:cNvSpPr>
+            <a:spLocks noGrp="1"/>
+          </p:cNvSpPr>
+          <p:nvPr>
+            <p:ph type="sldNum" sz="quarter" idx="5"/>
+          </p:nvPr>
+        </p:nvSpPr>
+        <p:spPr/>
+        <p:txBody>
+          <a:bodyPr/>
+          <a:lstStyle/>
+          <a:p>
+            <a:fld id="{8CBE09F5-4AE9-7A42-BE7A-80876203947F}" type="slidenum">
+              <a:rPr lang="nl-BE" smtClean="0"/>
+              <a:t>4</a:t>
+            </a:fld>
+            <a:endParaRPr lang="nl-BE"/>
+          </a:p>
+        </p:txBody>
+      </p:sp>
+    </p:spTree>
+    <p:extLst>
+      <p:ext uri="{BB962C8B-B14F-4D97-AF65-F5344CB8AC3E}">
+        <p14:creationId xmlns:p14="http://schemas.microsoft.com/office/powerpoint/2010/main" val="3719700899"/>
+      </p:ext>
+    </p:extLst>
+  </p:cSld>
+  <p:clrMapOvr>
+    <a:masterClrMapping/>
+  </p:clrMapOvr>
+</p:notes>
 </file>
 
 <file path=ppt/slideLayouts/slideLayout1.xml><?xml version="1.0" encoding="utf-8"?>
@@ -154,10 +607,9 @@
           <a:lstStyle/>
           <a:p>
             <a:r>
-              <a:rPr lang="en-US" smtClean="0"/>
+              <a:rPr lang="en-US"/>
               <a:t>Click to edit Master title style</a:t>
             </a:r>
-            <a:endParaRPr lang="en-US"/>
           </a:p>
         </p:txBody>
       </p:sp>
@@ -273,10 +725,9 @@
           </a:lstStyle>
           <a:p>
             <a:r>
-              <a:rPr lang="en-US" smtClean="0"/>
+              <a:rPr lang="en-US"/>
               <a:t>Click to edit Master subtitle style</a:t>
             </a:r>
-            <a:endParaRPr lang="en-US"/>
           </a:p>
         </p:txBody>
       </p:sp>
@@ -297,7 +748,7 @@
           <a:p>
             <a:fld id="{5BCAD085-E8A6-8845-BD4E-CB4CCA059FC4}" type="datetimeFigureOut">
               <a:rPr lang="en-US" smtClean="0"/>
-              <a:t>1/27/13</a:t>
+              <a:t>5/30/26</a:t>
             </a:fld>
             <a:endParaRPr lang="en-US"/>
           </a:p>
@@ -339,7 +790,7 @@
           <a:p>
             <a:fld id="{C1FF6DA9-008F-8B48-92A6-B652298478BF}" type="slidenum">
               <a:rPr lang="en-US" smtClean="0"/>
-              <a:t>‹#›</a:t>
+              <a:t>‹nr.›</a:t>
             </a:fld>
             <a:endParaRPr lang="en-US"/>
           </a:p>
@@ -391,10 +842,9 @@
           <a:lstStyle/>
           <a:p>
             <a:r>
-              <a:rPr lang="en-US" smtClean="0"/>
+              <a:rPr lang="en-US"/>
               <a:t>Click to edit Master title style</a:t>
             </a:r>
-            <a:endParaRPr lang="en-US"/>
           </a:p>
         </p:txBody>
       </p:sp>
@@ -415,38 +865,37 @@
           <a:p>
             <a:pPr lvl="0"/>
             <a:r>
-              <a:rPr lang="en-US" smtClean="0"/>
+              <a:rPr lang="en-US"/>
               <a:t>Click to edit Master text styles</a:t>
             </a:r>
           </a:p>
           <a:p>
             <a:pPr lvl="1"/>
             <a:r>
-              <a:rPr lang="en-US" smtClean="0"/>
+              <a:rPr lang="en-US"/>
               <a:t>Second level</a:t>
             </a:r>
           </a:p>
           <a:p>
             <a:pPr lvl="2"/>
             <a:r>
-              <a:rPr lang="en-US" smtClean="0"/>
+              <a:rPr lang="en-US"/>
               <a:t>Third level</a:t>
             </a:r>
           </a:p>
           <a:p>
             <a:pPr lvl="3"/>
             <a:r>
-              <a:rPr lang="en-US" smtClean="0"/>
+              <a:rPr lang="en-US"/>
               <a:t>Fourth level</a:t>
             </a:r>
           </a:p>
           <a:p>
             <a:pPr lvl="4"/>
             <a:r>
-              <a:rPr lang="en-US" smtClean="0"/>
+              <a:rPr lang="en-US"/>
               <a:t>Fifth level</a:t>
             </a:r>
-            <a:endParaRPr lang="en-US"/>
           </a:p>
         </p:txBody>
       </p:sp>
@@ -467,7 +916,7 @@
           <a:p>
             <a:fld id="{5BCAD085-E8A6-8845-BD4E-CB4CCA059FC4}" type="datetimeFigureOut">
               <a:rPr lang="en-US" smtClean="0"/>
-              <a:t>1/27/13</a:t>
+              <a:t>5/30/26</a:t>
             </a:fld>
             <a:endParaRPr lang="en-US"/>
           </a:p>
@@ -509,7 +958,7 @@
           <a:p>
             <a:fld id="{C1FF6DA9-008F-8B48-92A6-B652298478BF}" type="slidenum">
               <a:rPr lang="en-US" smtClean="0"/>
-              <a:t>‹#›</a:t>
+              <a:t>‹nr.›</a:t>
             </a:fld>
             <a:endParaRPr lang="en-US"/>
           </a:p>
@@ -566,10 +1015,9 @@
           <a:lstStyle/>
           <a:p>
             <a:r>
-              <a:rPr lang="en-US" smtClean="0"/>
+              <a:rPr lang="en-US"/>
               <a:t>Click to edit Master title style</a:t>
             </a:r>
-            <a:endParaRPr lang="en-US"/>
           </a:p>
         </p:txBody>
       </p:sp>
@@ -595,38 +1043,37 @@
           <a:p>
             <a:pPr lvl="0"/>
             <a:r>
-              <a:rPr lang="en-US" smtClean="0"/>
+              <a:rPr lang="en-US"/>
               <a:t>Click to edit Master text styles</a:t>
             </a:r>
           </a:p>
           <a:p>
             <a:pPr lvl="1"/>
             <a:r>
-              <a:rPr lang="en-US" smtClean="0"/>
+              <a:rPr lang="en-US"/>
               <a:t>Second level</a:t>
             </a:r>
           </a:p>
           <a:p>
             <a:pPr lvl="2"/>
             <a:r>
-              <a:rPr lang="en-US" smtClean="0"/>
+              <a:rPr lang="en-US"/>
               <a:t>Third level</a:t>
             </a:r>
           </a:p>
           <a:p>
             <a:pPr lvl="3"/>
             <a:r>
-              <a:rPr lang="en-US" smtClean="0"/>
+              <a:rPr lang="en-US"/>
               <a:t>Fourth level</a:t>
             </a:r>
           </a:p>
           <a:p>
             <a:pPr lvl="4"/>
             <a:r>
-              <a:rPr lang="en-US" smtClean="0"/>
+              <a:rPr lang="en-US"/>
               <a:t>Fifth level</a:t>
             </a:r>
-            <a:endParaRPr lang="en-US"/>
           </a:p>
         </p:txBody>
       </p:sp>
@@ -647,7 +1094,7 @@
           <a:p>
             <a:fld id="{5BCAD085-E8A6-8845-BD4E-CB4CCA059FC4}" type="datetimeFigureOut">
               <a:rPr lang="en-US" smtClean="0"/>
-              <a:t>1/27/13</a:t>
+              <a:t>5/30/26</a:t>
             </a:fld>
             <a:endParaRPr lang="en-US"/>
           </a:p>
@@ -689,7 +1136,7 @@
           <a:p>
             <a:fld id="{C1FF6DA9-008F-8B48-92A6-B652298478BF}" type="slidenum">
               <a:rPr lang="en-US" smtClean="0"/>
-              <a:t>‹#›</a:t>
+              <a:t>‹nr.›</a:t>
             </a:fld>
             <a:endParaRPr lang="en-US"/>
           </a:p>
@@ -741,10 +1188,9 @@
           <a:lstStyle/>
           <a:p>
             <a:r>
-              <a:rPr lang="en-US" smtClean="0"/>
+              <a:rPr lang="en-US"/>
               <a:t>Click to edit Master title style</a:t>
             </a:r>
-            <a:endParaRPr lang="en-US"/>
           </a:p>
         </p:txBody>
       </p:sp>
@@ -765,38 +1211,37 @@
           <a:p>
             <a:pPr lvl="0"/>
             <a:r>
-              <a:rPr lang="en-US" smtClean="0"/>
+              <a:rPr lang="en-US"/>
               <a:t>Click to edit Master text styles</a:t>
             </a:r>
           </a:p>
           <a:p>
             <a:pPr lvl="1"/>
             <a:r>
-              <a:rPr lang="en-US" smtClean="0"/>
+              <a:rPr lang="en-US"/>
               <a:t>Second level</a:t>
             </a:r>
           </a:p>
           <a:p>
             <a:pPr lvl="2"/>
             <a:r>
-              <a:rPr lang="en-US" smtClean="0"/>
+              <a:rPr lang="en-US"/>
               <a:t>Third level</a:t>
             </a:r>
           </a:p>
           <a:p>
             <a:pPr lvl="3"/>
             <a:r>
-              <a:rPr lang="en-US" smtClean="0"/>
+              <a:rPr lang="en-US"/>
               <a:t>Fourth level</a:t>
             </a:r>
           </a:p>
           <a:p>
             <a:pPr lvl="4"/>
             <a:r>
-              <a:rPr lang="en-US" smtClean="0"/>
+              <a:rPr lang="en-US"/>
               <a:t>Fifth level</a:t>
             </a:r>
-            <a:endParaRPr lang="en-US"/>
           </a:p>
         </p:txBody>
       </p:sp>
@@ -817,7 +1262,7 @@
           <a:p>
             <a:fld id="{5BCAD085-E8A6-8845-BD4E-CB4CCA059FC4}" type="datetimeFigureOut">
               <a:rPr lang="en-US" smtClean="0"/>
-              <a:t>1/27/13</a:t>
+              <a:t>5/30/26</a:t>
             </a:fld>
             <a:endParaRPr lang="en-US"/>
           </a:p>
@@ -859,7 +1304,7 @@
           <a:p>
             <a:fld id="{C1FF6DA9-008F-8B48-92A6-B652298478BF}" type="slidenum">
               <a:rPr lang="en-US" smtClean="0"/>
-              <a:t>‹#›</a:t>
+              <a:t>‹nr.›</a:t>
             </a:fld>
             <a:endParaRPr lang="en-US"/>
           </a:p>
@@ -920,10 +1365,9 @@
           </a:lstStyle>
           <a:p>
             <a:r>
-              <a:rPr lang="en-US" smtClean="0"/>
+              <a:rPr lang="en-US"/>
               <a:t>Click to edit Master title style</a:t>
             </a:r>
-            <a:endParaRPr lang="en-US"/>
           </a:p>
         </p:txBody>
       </p:sp>
@@ -1040,7 +1484,7 @@
           <a:p>
             <a:pPr lvl="0"/>
             <a:r>
-              <a:rPr lang="en-US" smtClean="0"/>
+              <a:rPr lang="en-US"/>
               <a:t>Click to edit Master text styles</a:t>
             </a:r>
           </a:p>
@@ -1063,7 +1507,7 @@
           <a:p>
             <a:fld id="{5BCAD085-E8A6-8845-BD4E-CB4CCA059FC4}" type="datetimeFigureOut">
               <a:rPr lang="en-US" smtClean="0"/>
-              <a:t>1/27/13</a:t>
+              <a:t>5/30/26</a:t>
             </a:fld>
             <a:endParaRPr lang="en-US"/>
           </a:p>
@@ -1105,7 +1549,7 @@
           <a:p>
             <a:fld id="{C1FF6DA9-008F-8B48-92A6-B652298478BF}" type="slidenum">
               <a:rPr lang="en-US" smtClean="0"/>
-              <a:t>‹#›</a:t>
+              <a:t>‹nr.›</a:t>
             </a:fld>
             <a:endParaRPr lang="en-US"/>
           </a:p>
@@ -1157,10 +1601,9 @@
           <a:lstStyle/>
           <a:p>
             <a:r>
-              <a:rPr lang="en-US" smtClean="0"/>
+              <a:rPr lang="en-US"/>
               <a:t>Click to edit Master title style</a:t>
             </a:r>
-            <a:endParaRPr lang="en-US"/>
           </a:p>
         </p:txBody>
       </p:sp>
@@ -1214,38 +1657,37 @@
           <a:p>
             <a:pPr lvl="0"/>
             <a:r>
-              <a:rPr lang="en-US" smtClean="0"/>
+              <a:rPr lang="en-US"/>
               <a:t>Click to edit Master text styles</a:t>
             </a:r>
           </a:p>
           <a:p>
             <a:pPr lvl="1"/>
             <a:r>
-              <a:rPr lang="en-US" smtClean="0"/>
+              <a:rPr lang="en-US"/>
               <a:t>Second level</a:t>
             </a:r>
           </a:p>
           <a:p>
             <a:pPr lvl="2"/>
             <a:r>
-              <a:rPr lang="en-US" smtClean="0"/>
+              <a:rPr lang="en-US"/>
               <a:t>Third level</a:t>
             </a:r>
           </a:p>
           <a:p>
             <a:pPr lvl="3"/>
             <a:r>
-              <a:rPr lang="en-US" smtClean="0"/>
+              <a:rPr lang="en-US"/>
               <a:t>Fourth level</a:t>
             </a:r>
           </a:p>
           <a:p>
             <a:pPr lvl="4"/>
             <a:r>
-              <a:rPr lang="en-US" smtClean="0"/>
+              <a:rPr lang="en-US"/>
               <a:t>Fifth level</a:t>
             </a:r>
-            <a:endParaRPr lang="en-US"/>
           </a:p>
         </p:txBody>
       </p:sp>
@@ -1299,38 +1741,37 @@
           <a:p>
             <a:pPr lvl="0"/>
             <a:r>
-              <a:rPr lang="en-US" smtClean="0"/>
+              <a:rPr lang="en-US"/>
               <a:t>Click to edit Master text styles</a:t>
             </a:r>
           </a:p>
           <a:p>
             <a:pPr lvl="1"/>
             <a:r>
-              <a:rPr lang="en-US" smtClean="0"/>
+              <a:rPr lang="en-US"/>
               <a:t>Second level</a:t>
             </a:r>
           </a:p>
           <a:p>
             <a:pPr lvl="2"/>
             <a:r>
-              <a:rPr lang="en-US" smtClean="0"/>
+              <a:rPr lang="en-US"/>
               <a:t>Third level</a:t>
             </a:r>
           </a:p>
           <a:p>
             <a:pPr lvl="3"/>
             <a:r>
-              <a:rPr lang="en-US" smtClean="0"/>
+              <a:rPr lang="en-US"/>
               <a:t>Fourth level</a:t>
             </a:r>
           </a:p>
           <a:p>
             <a:pPr lvl="4"/>
             <a:r>
-              <a:rPr lang="en-US" smtClean="0"/>
+              <a:rPr lang="en-US"/>
               <a:t>Fifth level</a:t>
             </a:r>
-            <a:endParaRPr lang="en-US"/>
           </a:p>
         </p:txBody>
       </p:sp>
@@ -1351,7 +1792,7 @@
           <a:p>
             <a:fld id="{5BCAD085-E8A6-8845-BD4E-CB4CCA059FC4}" type="datetimeFigureOut">
               <a:rPr lang="en-US" smtClean="0"/>
-              <a:t>1/27/13</a:t>
+              <a:t>5/30/26</a:t>
             </a:fld>
             <a:endParaRPr lang="en-US"/>
           </a:p>
@@ -1393,7 +1834,7 @@
           <a:p>
             <a:fld id="{C1FF6DA9-008F-8B48-92A6-B652298478BF}" type="slidenum">
               <a:rPr lang="en-US" smtClean="0"/>
-              <a:t>‹#›</a:t>
+              <a:t>‹nr.›</a:t>
             </a:fld>
             <a:endParaRPr lang="en-US"/>
           </a:p>
@@ -1449,10 +1890,9 @@
           </a:lstStyle>
           <a:p>
             <a:r>
-              <a:rPr lang="en-US" smtClean="0"/>
+              <a:rPr lang="en-US"/>
               <a:t>Click to edit Master title style</a:t>
             </a:r>
-            <a:endParaRPr lang="en-US"/>
           </a:p>
         </p:txBody>
       </p:sp>
@@ -1515,7 +1955,7 @@
           <a:p>
             <a:pPr lvl="0"/>
             <a:r>
-              <a:rPr lang="en-US" smtClean="0"/>
+              <a:rPr lang="en-US"/>
               <a:t>Click to edit Master text styles</a:t>
             </a:r>
           </a:p>
@@ -1571,38 +2011,37 @@
           <a:p>
             <a:pPr lvl="0"/>
             <a:r>
-              <a:rPr lang="en-US" smtClean="0"/>
+              <a:rPr lang="en-US"/>
               <a:t>Click to edit Master text styles</a:t>
             </a:r>
           </a:p>
           <a:p>
             <a:pPr lvl="1"/>
             <a:r>
-              <a:rPr lang="en-US" smtClean="0"/>
+              <a:rPr lang="en-US"/>
               <a:t>Second level</a:t>
             </a:r>
           </a:p>
           <a:p>
             <a:pPr lvl="2"/>
             <a:r>
-              <a:rPr lang="en-US" smtClean="0"/>
+              <a:rPr lang="en-US"/>
               <a:t>Third level</a:t>
             </a:r>
           </a:p>
           <a:p>
             <a:pPr lvl="3"/>
             <a:r>
-              <a:rPr lang="en-US" smtClean="0"/>
+              <a:rPr lang="en-US"/>
               <a:t>Fourth level</a:t>
             </a:r>
           </a:p>
           <a:p>
             <a:pPr lvl="4"/>
             <a:r>
-              <a:rPr lang="en-US" smtClean="0"/>
+              <a:rPr lang="en-US"/>
               <a:t>Fifth level</a:t>
             </a:r>
-            <a:endParaRPr lang="en-US"/>
           </a:p>
         </p:txBody>
       </p:sp>
@@ -1665,7 +2104,7 @@
           <a:p>
             <a:pPr lvl="0"/>
             <a:r>
-              <a:rPr lang="en-US" smtClean="0"/>
+              <a:rPr lang="en-US"/>
               <a:t>Click to edit Master text styles</a:t>
             </a:r>
           </a:p>
@@ -1721,38 +2160,37 @@
           <a:p>
             <a:pPr lvl="0"/>
             <a:r>
-              <a:rPr lang="en-US" smtClean="0"/>
+              <a:rPr lang="en-US"/>
               <a:t>Click to edit Master text styles</a:t>
             </a:r>
           </a:p>
           <a:p>
             <a:pPr lvl="1"/>
             <a:r>
-              <a:rPr lang="en-US" smtClean="0"/>
+              <a:rPr lang="en-US"/>
               <a:t>Second level</a:t>
             </a:r>
           </a:p>
           <a:p>
             <a:pPr lvl="2"/>
             <a:r>
-              <a:rPr lang="en-US" smtClean="0"/>
+              <a:rPr lang="en-US"/>
               <a:t>Third level</a:t>
             </a:r>
           </a:p>
           <a:p>
             <a:pPr lvl="3"/>
             <a:r>
-              <a:rPr lang="en-US" smtClean="0"/>
+              <a:rPr lang="en-US"/>
               <a:t>Fourth level</a:t>
             </a:r>
           </a:p>
           <a:p>
             <a:pPr lvl="4"/>
             <a:r>
-              <a:rPr lang="en-US" smtClean="0"/>
+              <a:rPr lang="en-US"/>
               <a:t>Fifth level</a:t>
             </a:r>
-            <a:endParaRPr lang="en-US"/>
           </a:p>
         </p:txBody>
       </p:sp>
@@ -1773,7 +2211,7 @@
           <a:p>
             <a:fld id="{5BCAD085-E8A6-8845-BD4E-CB4CCA059FC4}" type="datetimeFigureOut">
               <a:rPr lang="en-US" smtClean="0"/>
-              <a:t>1/27/13</a:t>
+              <a:t>5/30/26</a:t>
             </a:fld>
             <a:endParaRPr lang="en-US"/>
           </a:p>
@@ -1815,7 +2253,7 @@
           <a:p>
             <a:fld id="{C1FF6DA9-008F-8B48-92A6-B652298478BF}" type="slidenum">
               <a:rPr lang="en-US" smtClean="0"/>
-              <a:t>‹#›</a:t>
+              <a:t>‹nr.›</a:t>
             </a:fld>
             <a:endParaRPr lang="en-US"/>
           </a:p>
@@ -1867,10 +2305,9 @@
           <a:lstStyle/>
           <a:p>
             <a:r>
-              <a:rPr lang="en-US" smtClean="0"/>
+              <a:rPr lang="en-US"/>
               <a:t>Click to edit Master title style</a:t>
             </a:r>
-            <a:endParaRPr lang="en-US"/>
           </a:p>
         </p:txBody>
       </p:sp>
@@ -1891,7 +2328,7 @@
           <a:p>
             <a:fld id="{5BCAD085-E8A6-8845-BD4E-CB4CCA059FC4}" type="datetimeFigureOut">
               <a:rPr lang="en-US" smtClean="0"/>
-              <a:t>1/27/13</a:t>
+              <a:t>5/30/26</a:t>
             </a:fld>
             <a:endParaRPr lang="en-US"/>
           </a:p>
@@ -1933,7 +2370,7 @@
           <a:p>
             <a:fld id="{C1FF6DA9-008F-8B48-92A6-B652298478BF}" type="slidenum">
               <a:rPr lang="en-US" smtClean="0"/>
-              <a:t>‹#›</a:t>
+              <a:t>‹nr.›</a:t>
             </a:fld>
             <a:endParaRPr lang="en-US"/>
           </a:p>
@@ -1986,7 +2423,7 @@
           <a:p>
             <a:fld id="{5BCAD085-E8A6-8845-BD4E-CB4CCA059FC4}" type="datetimeFigureOut">
               <a:rPr lang="en-US" smtClean="0"/>
-              <a:t>1/27/13</a:t>
+              <a:t>5/30/26</a:t>
             </a:fld>
             <a:endParaRPr lang="en-US"/>
           </a:p>
@@ -2028,7 +2465,7 @@
           <a:p>
             <a:fld id="{C1FF6DA9-008F-8B48-92A6-B652298478BF}" type="slidenum">
               <a:rPr lang="en-US" smtClean="0"/>
-              <a:t>‹#›</a:t>
+              <a:t>‹nr.›</a:t>
             </a:fld>
             <a:endParaRPr lang="en-US"/>
           </a:p>
@@ -2089,10 +2526,9 @@
           </a:lstStyle>
           <a:p>
             <a:r>
-              <a:rPr lang="en-US" smtClean="0"/>
+              <a:rPr lang="en-US"/>
               <a:t>Click to edit Master title style</a:t>
             </a:r>
-            <a:endParaRPr lang="en-US"/>
           </a:p>
         </p:txBody>
       </p:sp>
@@ -2146,38 +2582,37 @@
           <a:p>
             <a:pPr lvl="0"/>
             <a:r>
-              <a:rPr lang="en-US" smtClean="0"/>
+              <a:rPr lang="en-US"/>
               <a:t>Click to edit Master text styles</a:t>
             </a:r>
           </a:p>
           <a:p>
             <a:pPr lvl="1"/>
             <a:r>
-              <a:rPr lang="en-US" smtClean="0"/>
+              <a:rPr lang="en-US"/>
               <a:t>Second level</a:t>
             </a:r>
           </a:p>
           <a:p>
             <a:pPr lvl="2"/>
             <a:r>
-              <a:rPr lang="en-US" smtClean="0"/>
+              <a:rPr lang="en-US"/>
               <a:t>Third level</a:t>
             </a:r>
           </a:p>
           <a:p>
             <a:pPr lvl="3"/>
             <a:r>
-              <a:rPr lang="en-US" smtClean="0"/>
+              <a:rPr lang="en-US"/>
               <a:t>Fourth level</a:t>
             </a:r>
           </a:p>
           <a:p>
             <a:pPr lvl="4"/>
             <a:r>
-              <a:rPr lang="en-US" smtClean="0"/>
+              <a:rPr lang="en-US"/>
               <a:t>Fifth level</a:t>
             </a:r>
-            <a:endParaRPr lang="en-US"/>
           </a:p>
         </p:txBody>
       </p:sp>
@@ -2240,7 +2675,7 @@
           <a:p>
             <a:pPr lvl="0"/>
             <a:r>
-              <a:rPr lang="en-US" smtClean="0"/>
+              <a:rPr lang="en-US"/>
               <a:t>Click to edit Master text styles</a:t>
             </a:r>
           </a:p>
@@ -2263,7 +2698,7 @@
           <a:p>
             <a:fld id="{5BCAD085-E8A6-8845-BD4E-CB4CCA059FC4}" type="datetimeFigureOut">
               <a:rPr lang="en-US" smtClean="0"/>
-              <a:t>1/27/13</a:t>
+              <a:t>5/30/26</a:t>
             </a:fld>
             <a:endParaRPr lang="en-US"/>
           </a:p>
@@ -2305,7 +2740,7 @@
           <a:p>
             <a:fld id="{C1FF6DA9-008F-8B48-92A6-B652298478BF}" type="slidenum">
               <a:rPr lang="en-US" smtClean="0"/>
-              <a:t>‹#›</a:t>
+              <a:t>‹nr.›</a:t>
             </a:fld>
             <a:endParaRPr lang="en-US"/>
           </a:p>
@@ -2366,10 +2801,9 @@
           </a:lstStyle>
           <a:p>
             <a:r>
-              <a:rPr lang="en-US" smtClean="0"/>
+              <a:rPr lang="en-US"/>
               <a:t>Click to edit Master title style</a:t>
             </a:r>
-            <a:endParaRPr lang="en-US"/>
           </a:p>
         </p:txBody>
       </p:sp>
@@ -2493,7 +2927,7 @@
           <a:p>
             <a:pPr lvl="0"/>
             <a:r>
-              <a:rPr lang="en-US" smtClean="0"/>
+              <a:rPr lang="en-US"/>
               <a:t>Click to edit Master text styles</a:t>
             </a:r>
           </a:p>
@@ -2516,7 +2950,7 @@
           <a:p>
             <a:fld id="{5BCAD085-E8A6-8845-BD4E-CB4CCA059FC4}" type="datetimeFigureOut">
               <a:rPr lang="en-US" smtClean="0"/>
-              <a:t>1/27/13</a:t>
+              <a:t>5/30/26</a:t>
             </a:fld>
             <a:endParaRPr lang="en-US"/>
           </a:p>
@@ -2558,7 +2992,7 @@
           <a:p>
             <a:fld id="{C1FF6DA9-008F-8B48-92A6-B652298478BF}" type="slidenum">
               <a:rPr lang="en-US" smtClean="0"/>
-              <a:t>‹#›</a:t>
+              <a:t>‹nr.›</a:t>
             </a:fld>
             <a:endParaRPr lang="en-US"/>
           </a:p>
@@ -2625,10 +3059,9 @@
           <a:lstStyle/>
           <a:p>
             <a:r>
-              <a:rPr lang="en-US" smtClean="0"/>
+              <a:rPr lang="en-US"/>
               <a:t>Click to edit Master title style</a:t>
             </a:r>
-            <a:endParaRPr lang="en-US"/>
           </a:p>
         </p:txBody>
       </p:sp>
@@ -2659,38 +3092,37 @@
           <a:p>
             <a:pPr lvl="0"/>
             <a:r>
-              <a:rPr lang="en-US" smtClean="0"/>
+              <a:rPr lang="en-US"/>
               <a:t>Click to edit Master text styles</a:t>
             </a:r>
           </a:p>
           <a:p>
             <a:pPr lvl="1"/>
             <a:r>
-              <a:rPr lang="en-US" smtClean="0"/>
+              <a:rPr lang="en-US"/>
               <a:t>Second level</a:t>
             </a:r>
           </a:p>
           <a:p>
             <a:pPr lvl="2"/>
             <a:r>
-              <a:rPr lang="en-US" smtClean="0"/>
+              <a:rPr lang="en-US"/>
               <a:t>Third level</a:t>
             </a:r>
           </a:p>
           <a:p>
             <a:pPr lvl="3"/>
             <a:r>
-              <a:rPr lang="en-US" smtClean="0"/>
+              <a:rPr lang="en-US"/>
               <a:t>Fourth level</a:t>
             </a:r>
           </a:p>
           <a:p>
             <a:pPr lvl="4"/>
             <a:r>
-              <a:rPr lang="en-US" smtClean="0"/>
+              <a:rPr lang="en-US"/>
               <a:t>Fifth level</a:t>
             </a:r>
-            <a:endParaRPr lang="en-US"/>
           </a:p>
         </p:txBody>
       </p:sp>
@@ -2729,7 +3161,7 @@
           <a:p>
             <a:fld id="{5BCAD085-E8A6-8845-BD4E-CB4CCA059FC4}" type="datetimeFigureOut">
               <a:rPr lang="en-US" smtClean="0"/>
-              <a:t>1/27/13</a:t>
+              <a:t>5/30/26</a:t>
             </a:fld>
             <a:endParaRPr lang="en-US"/>
           </a:p>
@@ -2807,7 +3239,7 @@
           <a:p>
             <a:fld id="{C1FF6DA9-008F-8B48-92A6-B652298478BF}" type="slidenum">
               <a:rPr lang="en-US" smtClean="0"/>
-              <a:t>‹#›</a:t>
+              <a:t>‹nr.›</a:t>
             </a:fld>
             <a:endParaRPr lang="en-US"/>
           </a:p>
@@ -3088,7 +3520,7 @@
 </file>
 
 <file path=ppt/slides/slide1.xml><?xml version="1.0" encoding="utf-8"?>
-<p:sld xmlns:a="http://schemas.openxmlformats.org/drawingml/2006/main" xmlns:p="http://schemas.openxmlformats.org/presentationml/2006/main" xmlns:r="http://schemas.openxmlformats.org/officeDocument/2006/relationships">
+<p:sld xmlns:a="http://schemas.openxmlformats.org/drawingml/2006/main" xmlns:r="http://schemas.openxmlformats.org/officeDocument/2006/relationships" xmlns:p="http://schemas.openxmlformats.org/presentationml/2006/main">
   <p:cSld>
     <p:spTree>
       <p:nvGrpSpPr>
@@ -3096,7 +3528,14 @@
         <p:cNvGrpSpPr/>
         <p:nvPr/>
       </p:nvGrpSpPr>
-      <p:grpSpPr/>
+      <p:grpSpPr>
+        <a:xfrm>
+          <a:off x="0" y="0"/>
+          <a:ext cx="0" cy="0"/>
+          <a:chOff x="0" y="0"/>
+          <a:chExt cx="0" cy="0"/>
+        </a:xfrm>
+      </p:grpSpPr>
       <p:sp>
         <p:nvSpPr>
           <p:cNvPr id="2" name="Rectangle 1"/>
@@ -3137,6 +3576,7 @@
           <a:lstStyle/>
           <a:p>
             <a:pPr algn="ctr"/>
+            <a:endParaRPr/>
           </a:p>
         </p:txBody>
       </p:sp>
@@ -3180,6 +3620,7 @@
           <a:lstStyle/>
           <a:p>
             <a:pPr algn="ctr"/>
+            <a:endParaRPr/>
           </a:p>
         </p:txBody>
       </p:sp>
@@ -3223,6 +3664,7 @@
           <a:lstStyle/>
           <a:p>
             <a:pPr algn="ctr"/>
+            <a:endParaRPr/>
           </a:p>
         </p:txBody>
       </p:sp>
@@ -3266,6 +3708,7 @@
           <a:lstStyle/>
           <a:p>
             <a:pPr algn="ctr"/>
+            <a:endParaRPr/>
           </a:p>
         </p:txBody>
       </p:sp>
@@ -3448,7 +3891,7 @@
 </file>
 
 <file path=ppt/slides/slide10.xml><?xml version="1.0" encoding="utf-8"?>
-<p:sld xmlns:a="http://schemas.openxmlformats.org/drawingml/2006/main" xmlns:p="http://schemas.openxmlformats.org/presentationml/2006/main" xmlns:r="http://schemas.openxmlformats.org/officeDocument/2006/relationships">
+<p:sld xmlns:a="http://schemas.openxmlformats.org/drawingml/2006/main" xmlns:r="http://schemas.openxmlformats.org/officeDocument/2006/relationships" xmlns:p="http://schemas.openxmlformats.org/presentationml/2006/main">
   <p:cSld>
     <p:spTree>
       <p:nvGrpSpPr>
@@ -3456,7 +3899,14 @@
         <p:cNvGrpSpPr/>
         <p:nvPr/>
       </p:nvGrpSpPr>
-      <p:grpSpPr/>
+      <p:grpSpPr>
+        <a:xfrm>
+          <a:off x="0" y="0"/>
+          <a:ext cx="0" cy="0"/>
+          <a:chOff x="0" y="0"/>
+          <a:chExt cx="0" cy="0"/>
+        </a:xfrm>
+      </p:grpSpPr>
       <p:sp>
         <p:nvSpPr>
           <p:cNvPr id="2" name="Rectangle 1"/>
@@ -3497,6 +3947,7 @@
           <a:lstStyle/>
           <a:p>
             <a:pPr algn="ctr"/>
+            <a:endParaRPr/>
           </a:p>
         </p:txBody>
       </p:sp>
@@ -3540,6 +3991,7 @@
           <a:lstStyle/>
           <a:p>
             <a:pPr algn="ctr"/>
+            <a:endParaRPr/>
           </a:p>
         </p:txBody>
       </p:sp>
@@ -3651,6 +4103,7 @@
           <a:lstStyle/>
           <a:p>
             <a:pPr algn="ctr"/>
+            <a:endParaRPr/>
           </a:p>
         </p:txBody>
       </p:sp>
@@ -3694,6 +4147,7 @@
           <a:lstStyle/>
           <a:p>
             <a:pPr algn="ctr"/>
+            <a:endParaRPr/>
           </a:p>
         </p:txBody>
       </p:sp>
@@ -3752,7 +4206,9 @@
             <a:spAutoFit/>
           </a:bodyPr>
           <a:lstStyle/>
-          <a:p/>
+          <a:p>
+            <a:endParaRPr/>
+          </a:p>
           <a:p>
             <a:pPr algn="l">
               <a:spcBef>
@@ -3885,6 +4341,7 @@
           <a:lstStyle/>
           <a:p>
             <a:pPr algn="ctr"/>
+            <a:endParaRPr/>
           </a:p>
         </p:txBody>
       </p:sp>
@@ -3928,6 +4385,7 @@
           <a:lstStyle/>
           <a:p>
             <a:pPr algn="ctr"/>
+            <a:endParaRPr/>
           </a:p>
         </p:txBody>
       </p:sp>
@@ -3974,7 +4432,7 @@
         <p:spPr>
           <a:xfrm>
             <a:off x="6446520" y="2011680"/>
-            <a:ext cx="5212080" cy="3017520"/>
+            <a:ext cx="5212080" cy="2687915"/>
           </a:xfrm>
           <a:prstGeom prst="rect">
             <a:avLst/>
@@ -3986,7 +4444,9 @@
             <a:spAutoFit/>
           </a:bodyPr>
           <a:lstStyle/>
-          <a:p/>
+          <a:p>
+            <a:endParaRPr dirty="0"/>
+          </a:p>
           <a:p>
             <a:pPr algn="l">
               <a:spcBef>
@@ -3994,13 +4454,74 @@
               </a:spcBef>
             </a:pPr>
             <a:r>
-              <a:rPr sz="1300" b="0" i="0">
-                <a:solidFill>
-                  <a:srgbClr val="D0D8E8"/>
-                </a:solidFill>
-              </a:rPr>
-              <a:t>›  Rolgebaseerde toegang: alleen-lezen vs. beheerder</a:t>
-            </a:r>
+              <a:rPr sz="1300" b="0" i="0" dirty="0">
+                <a:solidFill>
+                  <a:srgbClr val="D0D8E8"/>
+                </a:solidFill>
+              </a:rPr>
+              <a:t>›  </a:t>
+            </a:r>
+            <a:r>
+              <a:rPr sz="1300" b="0" i="0" dirty="0" err="1">
+                <a:solidFill>
+                  <a:srgbClr val="D0D8E8"/>
+                </a:solidFill>
+              </a:rPr>
+              <a:t>Rolgebaseerde</a:t>
+            </a:r>
+            <a:r>
+              <a:rPr sz="1300" b="0" i="0" dirty="0">
+                <a:solidFill>
+                  <a:srgbClr val="D0D8E8"/>
+                </a:solidFill>
+              </a:rPr>
+              <a:t> </a:t>
+            </a:r>
+            <a:r>
+              <a:rPr sz="1300" b="0" i="0" dirty="0" err="1">
+                <a:solidFill>
+                  <a:srgbClr val="D0D8E8"/>
+                </a:solidFill>
+              </a:rPr>
+              <a:t>toegang</a:t>
+            </a:r>
+            <a:r>
+              <a:rPr sz="1300" b="0" i="0" dirty="0">
+                <a:solidFill>
+                  <a:srgbClr val="D0D8E8"/>
+                </a:solidFill>
+              </a:rPr>
+              <a:t>: </a:t>
+            </a:r>
+            <a:r>
+              <a:rPr sz="1300" b="0" i="0" dirty="0" err="1">
+                <a:solidFill>
+                  <a:srgbClr val="D0D8E8"/>
+                </a:solidFill>
+              </a:rPr>
+              <a:t>alleen-lezen</a:t>
+            </a:r>
+            <a:r>
+              <a:rPr sz="1300" b="0" i="0" dirty="0">
+                <a:solidFill>
+                  <a:srgbClr val="D0D8E8"/>
+                </a:solidFill>
+              </a:rPr>
+              <a:t> vs. </a:t>
+            </a:r>
+            <a:r>
+              <a:rPr sz="1300" b="0" i="0" dirty="0" err="1">
+                <a:solidFill>
+                  <a:srgbClr val="D0D8E8"/>
+                </a:solidFill>
+              </a:rPr>
+              <a:t>beheerder</a:t>
+            </a:r>
+            <a:endParaRPr sz="1300" b="0" i="0" dirty="0">
+              <a:solidFill>
+                <a:srgbClr val="D0D8E8"/>
+              </a:solidFill>
+            </a:endParaRPr>
           </a:p>
           <a:p>
             <a:pPr algn="l">
@@ -4009,13 +4530,58 @@
               </a:spcBef>
             </a:pPr>
             <a:r>
-              <a:rPr sz="1300" b="0" i="0">
-                <a:solidFill>
-                  <a:srgbClr val="D0D8E8"/>
-                </a:solidFill>
-              </a:rPr>
-              <a:t>›  Configureerbare drempelwaarden met e-mail-/Teams-meldingen</a:t>
-            </a:r>
+              <a:rPr sz="1300" b="0" i="0" dirty="0">
+                <a:solidFill>
+                  <a:srgbClr val="D0D8E8"/>
+                </a:solidFill>
+              </a:rPr>
+              <a:t>›  </a:t>
+            </a:r>
+            <a:r>
+              <a:rPr sz="1300" b="0" i="0" dirty="0" err="1">
+                <a:solidFill>
+                  <a:srgbClr val="D0D8E8"/>
+                </a:solidFill>
+              </a:rPr>
+              <a:t>Configureerbare</a:t>
+            </a:r>
+            <a:r>
+              <a:rPr sz="1300" b="0" i="0" dirty="0">
+                <a:solidFill>
+                  <a:srgbClr val="D0D8E8"/>
+                </a:solidFill>
+              </a:rPr>
+              <a:t> </a:t>
+            </a:r>
+            <a:r>
+              <a:rPr sz="1300" b="0" i="0" dirty="0" err="1">
+                <a:solidFill>
+                  <a:srgbClr val="D0D8E8"/>
+                </a:solidFill>
+              </a:rPr>
+              <a:t>drempelwaarden</a:t>
+            </a:r>
+            <a:r>
+              <a:rPr sz="1300" b="0" i="0" dirty="0">
+                <a:solidFill>
+                  <a:srgbClr val="D0D8E8"/>
+                </a:solidFill>
+              </a:rPr>
+              <a:t> met e-mail-/Teams-</a:t>
+            </a:r>
+            <a:r>
+              <a:rPr sz="1300" b="0" i="0" dirty="0" err="1">
+                <a:solidFill>
+                  <a:srgbClr val="D0D8E8"/>
+                </a:solidFill>
+              </a:rPr>
+              <a:t>meldingen</a:t>
+            </a:r>
+            <a:endParaRPr sz="1300" b="0" i="0" dirty="0">
+              <a:solidFill>
+                <a:srgbClr val="D0D8E8"/>
+              </a:solidFill>
+            </a:endParaRPr>
           </a:p>
           <a:p>
             <a:pPr algn="l">
@@ -4024,13 +4590,74 @@
               </a:spcBef>
             </a:pPr>
             <a:r>
-              <a:rPr sz="1300" b="0" i="0">
-                <a:solidFill>
-                  <a:srgbClr val="D0D8E8"/>
-                </a:solidFill>
-              </a:rPr>
-              <a:t>›  Uitgebreide heatmap: inzoomen op individuele foutcodes</a:t>
-            </a:r>
+              <a:rPr sz="1300" b="0" i="0" dirty="0">
+                <a:solidFill>
+                  <a:srgbClr val="D0D8E8"/>
+                </a:solidFill>
+              </a:rPr>
+              <a:t>›  </a:t>
+            </a:r>
+            <a:r>
+              <a:rPr sz="1300" b="0" i="0" dirty="0" err="1">
+                <a:solidFill>
+                  <a:srgbClr val="D0D8E8"/>
+                </a:solidFill>
+              </a:rPr>
+              <a:t>Uitgebreide</a:t>
+            </a:r>
+            <a:r>
+              <a:rPr sz="1300" b="0" i="0" dirty="0">
+                <a:solidFill>
+                  <a:srgbClr val="D0D8E8"/>
+                </a:solidFill>
+              </a:rPr>
+              <a:t> heatmap: </a:t>
+            </a:r>
+            <a:r>
+              <a:rPr sz="1300" b="0" i="0" dirty="0" err="1">
+                <a:solidFill>
+                  <a:srgbClr val="D0D8E8"/>
+                </a:solidFill>
+              </a:rPr>
+              <a:t>inzoomen</a:t>
+            </a:r>
+            <a:r>
+              <a:rPr sz="1300" b="0" i="0" dirty="0">
+                <a:solidFill>
+                  <a:srgbClr val="D0D8E8"/>
+                </a:solidFill>
+              </a:rPr>
+              <a:t> op </a:t>
+            </a:r>
+            <a:r>
+              <a:rPr sz="1300" b="0" i="0" dirty="0" err="1">
+                <a:solidFill>
+                  <a:srgbClr val="D0D8E8"/>
+                </a:solidFill>
+              </a:rPr>
+              <a:t>individuele</a:t>
+            </a:r>
+            <a:r>
+              <a:rPr sz="1300" b="0" i="0" dirty="0">
+                <a:solidFill>
+                  <a:srgbClr val="D0D8E8"/>
+                </a:solidFill>
+              </a:rPr>
+              <a:t> </a:t>
+            </a:r>
+            <a:r>
+              <a:rPr sz="1300" b="0" i="0" dirty="0" err="1">
+                <a:solidFill>
+                  <a:srgbClr val="D0D8E8"/>
+                </a:solidFill>
+              </a:rPr>
+              <a:t>foutcodes</a:t>
+            </a:r>
+            <a:endParaRPr sz="1300" b="0" i="0" dirty="0">
+              <a:solidFill>
+                <a:srgbClr val="D0D8E8"/>
+              </a:solidFill>
+            </a:endParaRPr>
           </a:p>
           <a:p>
             <a:pPr algn="l">
@@ -4039,13 +4666,74 @@
               </a:spcBef>
             </a:pPr>
             <a:r>
-              <a:rPr sz="1300" b="0" i="0">
-                <a:solidFill>
-                  <a:srgbClr val="D0D8E8"/>
-                </a:solidFill>
-              </a:rPr>
-              <a:t>›  ML-foutvoorspelling naar productie brengen</a:t>
-            </a:r>
+              <a:rPr sz="1300" b="0" i="0" dirty="0">
+                <a:solidFill>
+                  <a:srgbClr val="D0D8E8"/>
+                </a:solidFill>
+              </a:rPr>
+              <a:t>›  ML-</a:t>
+            </a:r>
+            <a:r>
+              <a:rPr sz="1300" b="0" i="0" dirty="0" err="1">
+                <a:solidFill>
+                  <a:srgbClr val="D0D8E8"/>
+                </a:solidFill>
+              </a:rPr>
+              <a:t>foutvoorspelling</a:t>
+            </a:r>
+            <a:r>
+              <a:rPr sz="1300" b="0" i="0" dirty="0">
+                <a:solidFill>
+                  <a:srgbClr val="D0D8E8"/>
+                </a:solidFill>
+              </a:rPr>
+              <a:t> </a:t>
+            </a:r>
+            <a:r>
+              <a:rPr sz="1300" b="0" i="0" dirty="0" err="1">
+                <a:solidFill>
+                  <a:srgbClr val="D0D8E8"/>
+                </a:solidFill>
+              </a:rPr>
+              <a:t>naar</a:t>
+            </a:r>
+            <a:r>
+              <a:rPr sz="1300" b="0" i="0" dirty="0">
+                <a:solidFill>
+                  <a:srgbClr val="D0D8E8"/>
+                </a:solidFill>
+              </a:rPr>
+              <a:t> </a:t>
+            </a:r>
+            <a:r>
+              <a:rPr sz="1300" b="0" i="0" dirty="0" err="1">
+                <a:solidFill>
+                  <a:srgbClr val="D0D8E8"/>
+                </a:solidFill>
+              </a:rPr>
+              <a:t>productie</a:t>
+            </a:r>
+            <a:r>
+              <a:rPr sz="1300" b="0" i="0" dirty="0">
+                <a:solidFill>
+                  <a:srgbClr val="D0D8E8"/>
+                </a:solidFill>
+              </a:rPr>
+              <a:t> </a:t>
+            </a:r>
+            <a:r>
+              <a:rPr sz="1300" b="0" i="0" dirty="0" err="1">
+                <a:solidFill>
+                  <a:srgbClr val="D0D8E8"/>
+                </a:solidFill>
+              </a:rPr>
+              <a:t>brengen</a:t>
+            </a:r>
+            <a:endParaRPr sz="1300" b="0" i="0" dirty="0">
+              <a:solidFill>
+                <a:srgbClr val="D0D8E8"/>
+              </a:solidFill>
+            </a:endParaRPr>
           </a:p>
           <a:p>
             <a:pPr algn="l">
@@ -4054,12 +4742,108 @@
               </a:spcBef>
             </a:pPr>
             <a:r>
-              <a:rPr sz="1300" b="0" i="0">
-                <a:solidFill>
-                  <a:srgbClr val="D0D8E8"/>
-                </a:solidFill>
-              </a:rPr>
-              <a:t>›  Ondersteuning voor meerdere locaties (meerdere CIMPLICITY-instanties)</a:t>
+              <a:rPr sz="1300" b="0" i="0" dirty="0">
+                <a:solidFill>
+                  <a:srgbClr val="D0D8E8"/>
+                </a:solidFill>
+              </a:rPr>
+              <a:t>›  </a:t>
+            </a:r>
+            <a:r>
+              <a:rPr sz="1300" b="0" i="0" dirty="0" err="1">
+                <a:solidFill>
+                  <a:srgbClr val="D0D8E8"/>
+                </a:solidFill>
+              </a:rPr>
+              <a:t>Ondersteuning</a:t>
+            </a:r>
+            <a:r>
+              <a:rPr sz="1300" b="0" i="0" dirty="0">
+                <a:solidFill>
+                  <a:srgbClr val="D0D8E8"/>
+                </a:solidFill>
+              </a:rPr>
+              <a:t> </a:t>
+            </a:r>
+            <a:r>
+              <a:rPr sz="1300" b="0" i="0" dirty="0" err="1">
+                <a:solidFill>
+                  <a:srgbClr val="D0D8E8"/>
+                </a:solidFill>
+              </a:rPr>
+              <a:t>voor</a:t>
+            </a:r>
+            <a:r>
+              <a:rPr sz="1300" b="0" i="0" dirty="0">
+                <a:solidFill>
+                  <a:srgbClr val="D0D8E8"/>
+                </a:solidFill>
+              </a:rPr>
+              <a:t> </a:t>
+            </a:r>
+            <a:r>
+              <a:rPr sz="1300" b="0" i="0" dirty="0" err="1">
+                <a:solidFill>
+                  <a:srgbClr val="D0D8E8"/>
+                </a:solidFill>
+              </a:rPr>
+              <a:t>meerdere</a:t>
+            </a:r>
+            <a:r>
+              <a:rPr sz="1300" b="0" i="0" dirty="0">
+                <a:solidFill>
+                  <a:srgbClr val="D0D8E8"/>
+                </a:solidFill>
+              </a:rPr>
+              <a:t> </a:t>
+            </a:r>
+            <a:r>
+              <a:rPr sz="1300" b="0" i="0" dirty="0" err="1">
+                <a:solidFill>
+                  <a:srgbClr val="D0D8E8"/>
+                </a:solidFill>
+              </a:rPr>
+              <a:t>locaties</a:t>
+            </a:r>
+            <a:r>
+              <a:rPr sz="1300" b="0" i="0" dirty="0">
+                <a:solidFill>
+                  <a:srgbClr val="D0D8E8"/>
+                </a:solidFill>
+              </a:rPr>
+              <a:t> (</a:t>
+            </a:r>
+            <a:r>
+              <a:rPr sz="1300" b="0" i="0" dirty="0" err="1">
+                <a:solidFill>
+                  <a:srgbClr val="D0D8E8"/>
+                </a:solidFill>
+              </a:rPr>
+              <a:t>meerdere</a:t>
+            </a:r>
+            <a:r>
+              <a:rPr sz="1300" b="0" i="0" dirty="0">
+                <a:solidFill>
+                  <a:srgbClr val="D0D8E8"/>
+                </a:solidFill>
+              </a:rPr>
+              <a:t> CIMPLICITY-</a:t>
+            </a:r>
+            <a:r>
+              <a:rPr sz="1300" b="0" i="0" dirty="0" err="1">
+                <a:solidFill>
+                  <a:srgbClr val="D0D8E8"/>
+                </a:solidFill>
+              </a:rPr>
+              <a:t>instanties</a:t>
+            </a:r>
+            <a:r>
+              <a:rPr sz="1300" b="0" i="0" dirty="0">
+                <a:solidFill>
+                  <a:srgbClr val="D0D8E8"/>
+                </a:solidFill>
+              </a:rPr>
+              <a:t>)</a:t>
             </a:r>
           </a:p>
           <a:p>
@@ -4069,13 +4853,122 @@
               </a:spcBef>
             </a:pPr>
             <a:r>
-              <a:rPr sz="1300" b="0" i="0">
-                <a:solidFill>
-                  <a:srgbClr val="D0D8E8"/>
-                </a:solidFill>
-              </a:rPr>
-              <a:t>›  REST API zodat andere tools fouttrends kunnen opvragen</a:t>
-            </a:r>
+              <a:rPr sz="1300" b="0" i="0" dirty="0">
+                <a:solidFill>
+                  <a:srgbClr val="D0D8E8"/>
+                </a:solidFill>
+              </a:rPr>
+              <a:t>›  REST API </a:t>
+            </a:r>
+            <a:r>
+              <a:rPr sz="1300" b="0" i="0" dirty="0" err="1">
+                <a:solidFill>
+                  <a:srgbClr val="D0D8E8"/>
+                </a:solidFill>
+              </a:rPr>
+              <a:t>zodat</a:t>
+            </a:r>
+            <a:r>
+              <a:rPr sz="1300" b="0" i="0" dirty="0">
+                <a:solidFill>
+                  <a:srgbClr val="D0D8E8"/>
+                </a:solidFill>
+              </a:rPr>
+              <a:t> </a:t>
+            </a:r>
+            <a:r>
+              <a:rPr sz="1300" b="0" i="0" dirty="0" err="1">
+                <a:solidFill>
+                  <a:srgbClr val="D0D8E8"/>
+                </a:solidFill>
+              </a:rPr>
+              <a:t>andere</a:t>
+            </a:r>
+            <a:r>
+              <a:rPr sz="1300" b="0" i="0" dirty="0">
+                <a:solidFill>
+                  <a:srgbClr val="D0D8E8"/>
+                </a:solidFill>
+              </a:rPr>
+              <a:t> tools </a:t>
+            </a:r>
+            <a:r>
+              <a:rPr sz="1300" b="0" i="0" dirty="0" err="1">
+                <a:solidFill>
+                  <a:srgbClr val="D0D8E8"/>
+                </a:solidFill>
+              </a:rPr>
+              <a:t>fouttrends</a:t>
+            </a:r>
+            <a:r>
+              <a:rPr sz="1300" b="0" i="0" dirty="0">
+                <a:solidFill>
+                  <a:srgbClr val="D0D8E8"/>
+                </a:solidFill>
+              </a:rPr>
+              <a:t> </a:t>
+            </a:r>
+            <a:r>
+              <a:rPr sz="1300" b="0" i="0" dirty="0" err="1">
+                <a:solidFill>
+                  <a:srgbClr val="D0D8E8"/>
+                </a:solidFill>
+              </a:rPr>
+              <a:t>kunnen</a:t>
+            </a:r>
+            <a:r>
+              <a:rPr sz="1300" b="0" i="0" dirty="0">
+                <a:solidFill>
+                  <a:srgbClr val="D0D8E8"/>
+                </a:solidFill>
+              </a:rPr>
+              <a:t> </a:t>
+            </a:r>
+            <a:r>
+              <a:rPr sz="1300" b="0" i="0" dirty="0" err="1">
+                <a:solidFill>
+                  <a:srgbClr val="D0D8E8"/>
+                </a:solidFill>
+              </a:rPr>
+              <a:t>opvragen</a:t>
+            </a:r>
+            <a:endParaRPr lang="nl-BE" sz="1300" dirty="0">
+              <a:solidFill>
+                <a:srgbClr val="D0D8E8"/>
+              </a:solidFill>
+            </a:endParaRPr>
+          </a:p>
+          <a:p>
+            <a:pPr>
+              <a:spcBef>
+                <a:spcPts val="700"/>
+              </a:spcBef>
+            </a:pPr>
+            <a:r>
+              <a:rPr lang="nl-BE" sz="1300">
+                <a:solidFill>
+                  <a:srgbClr val="D0D8E8"/>
+                </a:solidFill>
+              </a:rPr>
+              <a:t>›  Onnodige fout selecties met de klant bekijken.</a:t>
+            </a:r>
+            <a:endParaRPr lang="nl-BE" sz="1300" dirty="0">
+              <a:solidFill>
+                <a:srgbClr val="D0D8E8"/>
+              </a:solidFill>
+            </a:endParaRPr>
+          </a:p>
+          <a:p>
+            <a:pPr algn="l">
+              <a:spcBef>
+                <a:spcPts val="700"/>
+              </a:spcBef>
+            </a:pPr>
+            <a:endParaRPr lang="nl-BE" sz="1300" b="0" i="0" dirty="0">
+              <a:solidFill>
+                <a:srgbClr val="D0D8E8"/>
+              </a:solidFill>
+            </a:endParaRPr>
           </a:p>
         </p:txBody>
       </p:sp>
@@ -4119,6 +5012,7 @@
           <a:lstStyle/>
           <a:p>
             <a:pPr algn="ctr"/>
+            <a:endParaRPr/>
           </a:p>
         </p:txBody>
       </p:sp>
@@ -4162,6 +5056,7 @@
           <a:lstStyle/>
           <a:p>
             <a:pPr algn="ctr"/>
+            <a:endParaRPr/>
           </a:p>
         </p:txBody>
       </p:sp>
@@ -4242,7 +5137,7 @@
 </file>
 
 <file path=ppt/slides/slide2.xml><?xml version="1.0" encoding="utf-8"?>
-<p:sld xmlns:a="http://schemas.openxmlformats.org/drawingml/2006/main" xmlns:p="http://schemas.openxmlformats.org/presentationml/2006/main" xmlns:r="http://schemas.openxmlformats.org/officeDocument/2006/relationships">
+<p:sld xmlns:a="http://schemas.openxmlformats.org/drawingml/2006/main" xmlns:r="http://schemas.openxmlformats.org/officeDocument/2006/relationships" xmlns:p="http://schemas.openxmlformats.org/presentationml/2006/main">
   <p:cSld>
     <p:spTree>
       <p:nvGrpSpPr>
@@ -4250,7 +5145,14 @@
         <p:cNvGrpSpPr/>
         <p:nvPr/>
       </p:nvGrpSpPr>
-      <p:grpSpPr/>
+      <p:grpSpPr>
+        <a:xfrm>
+          <a:off x="0" y="0"/>
+          <a:ext cx="0" cy="0"/>
+          <a:chOff x="0" y="0"/>
+          <a:chExt cx="0" cy="0"/>
+        </a:xfrm>
+      </p:grpSpPr>
       <p:sp>
         <p:nvSpPr>
           <p:cNvPr id="2" name="Rectangle 1"/>
@@ -4291,6 +5193,7 @@
           <a:lstStyle/>
           <a:p>
             <a:pPr algn="ctr"/>
+            <a:endParaRPr/>
           </a:p>
         </p:txBody>
       </p:sp>
@@ -4334,6 +5237,7 @@
           <a:lstStyle/>
           <a:p>
             <a:pPr algn="ctr"/>
+            <a:endParaRPr/>
           </a:p>
         </p:txBody>
       </p:sp>
@@ -4426,7 +5330,9 @@
             <a:spAutoFit/>
           </a:bodyPr>
           <a:lstStyle/>
-          <a:p/>
+          <a:p>
+            <a:endParaRPr/>
+          </a:p>
           <a:p>
             <a:pPr>
               <a:spcBef>
@@ -4441,14 +5347,6 @@
               </a:rPr>
               <a:t>  01  Projectbeschrijving &amp; probleemstelling</a:t>
             </a:r>
-            <a:r>
-              <a:rPr sz="1700">
-                <a:solidFill>
-                  <a:srgbClr val="FFFFFF"/>
-                </a:solidFill>
-              </a:rPr>
-              <a:t/>
-            </a:r>
           </a:p>
           <a:p>
             <a:pPr>
@@ -4464,14 +5362,6 @@
               </a:rPr>
               <a:t>  02  Doelen &amp; succescriteria</a:t>
             </a:r>
-            <a:r>
-              <a:rPr sz="1700">
-                <a:solidFill>
-                  <a:srgbClr val="FFFFFF"/>
-                </a:solidFill>
-              </a:rPr>
-              <a:t/>
-            </a:r>
           </a:p>
           <a:p>
             <a:pPr>
@@ -4487,14 +5377,6 @@
               </a:rPr>
               <a:t>  03  Team &amp; verantwoordelijkheden</a:t>
             </a:r>
-            <a:r>
-              <a:rPr sz="1700">
-                <a:solidFill>
-                  <a:srgbClr val="FFFFFF"/>
-                </a:solidFill>
-              </a:rPr>
-              <a:t/>
-            </a:r>
           </a:p>
           <a:p>
             <a:pPr>
@@ -4510,14 +5392,6 @@
               </a:rPr>
               <a:t>  04  Werkwijze &amp; methodologie</a:t>
             </a:r>
-            <a:r>
-              <a:rPr sz="1700">
-                <a:solidFill>
-                  <a:srgbClr val="FFFFFF"/>
-                </a:solidFill>
-              </a:rPr>
-              <a:t/>
-            </a:r>
           </a:p>
           <a:p>
             <a:pPr>
@@ -4533,14 +5407,6 @@
               </a:rPr>
               <a:t>  05  Architectuur</a:t>
             </a:r>
-            <a:r>
-              <a:rPr sz="1700">
-                <a:solidFill>
-                  <a:srgbClr val="FFFFFF"/>
-                </a:solidFill>
-              </a:rPr>
-              <a:t/>
-            </a:r>
           </a:p>
           <a:p>
             <a:pPr>
@@ -4556,14 +5422,6 @@
               </a:rPr>
               <a:t>  06  Overzicht sleutelfuncties</a:t>
             </a:r>
-            <a:r>
-              <a:rPr sz="1700">
-                <a:solidFill>
-                  <a:srgbClr val="FFFFFF"/>
-                </a:solidFill>
-              </a:rPr>
-              <a:t/>
-            </a:r>
           </a:p>
           <a:p>
             <a:pPr>
@@ -4579,14 +5437,6 @@
               </a:rPr>
               <a:t>  07  Voortgangstijdlijn</a:t>
             </a:r>
-            <a:r>
-              <a:rPr sz="1700">
-                <a:solidFill>
-                  <a:srgbClr val="FFFFFF"/>
-                </a:solidFill>
-              </a:rPr>
-              <a:t/>
-            </a:r>
           </a:p>
           <a:p>
             <a:pPr>
@@ -4601,14 +5451,6 @@
                 </a:solidFill>
               </a:rPr>
               <a:t>  08  Wat staat er nog te doen</a:t>
-            </a:r>
-            <a:r>
-              <a:rPr sz="1700">
-                <a:solidFill>
-                  <a:srgbClr val="FFFFFF"/>
-                </a:solidFill>
-              </a:rPr>
-              <a:t/>
             </a:r>
           </a:p>
         </p:txBody>
@@ -4622,7 +5464,7 @@
 </file>
 
 <file path=ppt/slides/slide3.xml><?xml version="1.0" encoding="utf-8"?>
-<p:sld xmlns:a="http://schemas.openxmlformats.org/drawingml/2006/main" xmlns:p="http://schemas.openxmlformats.org/presentationml/2006/main" xmlns:r="http://schemas.openxmlformats.org/officeDocument/2006/relationships">
+<p:sld xmlns:a="http://schemas.openxmlformats.org/drawingml/2006/main" xmlns:r="http://schemas.openxmlformats.org/officeDocument/2006/relationships" xmlns:p="http://schemas.openxmlformats.org/presentationml/2006/main">
   <p:cSld>
     <p:spTree>
       <p:nvGrpSpPr>
@@ -4630,7 +5472,14 @@
         <p:cNvGrpSpPr/>
         <p:nvPr/>
       </p:nvGrpSpPr>
-      <p:grpSpPr/>
+      <p:grpSpPr>
+        <a:xfrm>
+          <a:off x="0" y="0"/>
+          <a:ext cx="0" cy="0"/>
+          <a:chOff x="0" y="0"/>
+          <a:chExt cx="0" cy="0"/>
+        </a:xfrm>
+      </p:grpSpPr>
       <p:sp>
         <p:nvSpPr>
           <p:cNvPr id="2" name="Rectangle 1"/>
@@ -4671,6 +5520,7 @@
           <a:lstStyle/>
           <a:p>
             <a:pPr algn="ctr"/>
+            <a:endParaRPr/>
           </a:p>
         </p:txBody>
       </p:sp>
@@ -4714,6 +5564,7 @@
           <a:lstStyle/>
           <a:p>
             <a:pPr algn="ctr"/>
+            <a:endParaRPr/>
           </a:p>
         </p:txBody>
       </p:sp>
@@ -4825,6 +5676,7 @@
           <a:lstStyle/>
           <a:p>
             <a:pPr algn="ctr"/>
+            <a:endParaRPr/>
           </a:p>
         </p:txBody>
       </p:sp>
@@ -4868,6 +5720,7 @@
           <a:lstStyle/>
           <a:p>
             <a:pPr algn="ctr"/>
+            <a:endParaRPr/>
           </a:p>
         </p:txBody>
       </p:sp>
@@ -4911,6 +5764,7 @@
           <a:lstStyle/>
           <a:p>
             <a:pPr algn="ctr"/>
+            <a:endParaRPr/>
           </a:p>
         </p:txBody>
       </p:sp>
@@ -4969,7 +5823,9 @@
             <a:spAutoFit/>
           </a:bodyPr>
           <a:lstStyle/>
-          <a:p/>
+          <a:p>
+            <a:endParaRPr/>
+          </a:p>
           <a:p>
             <a:pPr algn="l">
               <a:spcBef>
@@ -5087,6 +5943,7 @@
           <a:lstStyle/>
           <a:p>
             <a:pPr algn="ctr"/>
+            <a:endParaRPr/>
           </a:p>
         </p:txBody>
       </p:sp>
@@ -5145,7 +6002,9 @@
             <a:spAutoFit/>
           </a:bodyPr>
           <a:lstStyle/>
-          <a:p/>
+          <a:p>
+            <a:endParaRPr/>
+          </a:p>
           <a:p>
             <a:pPr algn="l">
               <a:spcBef>
@@ -5247,7 +6106,7 @@
 </file>
 
 <file path=ppt/slides/slide4.xml><?xml version="1.0" encoding="utf-8"?>
-<p:sld xmlns:a="http://schemas.openxmlformats.org/drawingml/2006/main" xmlns:p="http://schemas.openxmlformats.org/presentationml/2006/main" xmlns:r="http://schemas.openxmlformats.org/officeDocument/2006/relationships">
+<p:sld xmlns:a="http://schemas.openxmlformats.org/drawingml/2006/main" xmlns:r="http://schemas.openxmlformats.org/officeDocument/2006/relationships" xmlns:p="http://schemas.openxmlformats.org/presentationml/2006/main">
   <p:cSld>
     <p:spTree>
       <p:nvGrpSpPr>
@@ -5255,7 +6114,14 @@
         <p:cNvGrpSpPr/>
         <p:nvPr/>
       </p:nvGrpSpPr>
-      <p:grpSpPr/>
+      <p:grpSpPr>
+        <a:xfrm>
+          <a:off x="0" y="0"/>
+          <a:ext cx="0" cy="0"/>
+          <a:chOff x="0" y="0"/>
+          <a:chExt cx="0" cy="0"/>
+        </a:xfrm>
+      </p:grpSpPr>
       <p:sp>
         <p:nvSpPr>
           <p:cNvPr id="2" name="Rectangle 1"/>
@@ -5296,6 +6162,7 @@
           <a:lstStyle/>
           <a:p>
             <a:pPr algn="ctr"/>
+            <a:endParaRPr/>
           </a:p>
         </p:txBody>
       </p:sp>
@@ -5339,6 +6206,7 @@
           <a:lstStyle/>
           <a:p>
             <a:pPr algn="ctr"/>
+            <a:endParaRPr/>
           </a:p>
         </p:txBody>
       </p:sp>
@@ -5450,6 +6318,7 @@
           <a:lstStyle/>
           <a:p>
             <a:pPr algn="ctr"/>
+            <a:endParaRPr/>
           </a:p>
         </p:txBody>
       </p:sp>
@@ -5561,6 +6430,7 @@
           <a:lstStyle/>
           <a:p>
             <a:pPr algn="ctr"/>
+            <a:endParaRPr/>
           </a:p>
         </p:txBody>
       </p:sp>
@@ -5672,6 +6542,7 @@
           <a:lstStyle/>
           <a:p>
             <a:pPr algn="ctr"/>
+            <a:endParaRPr/>
           </a:p>
         </p:txBody>
       </p:sp>
@@ -5783,6 +6654,7 @@
           <a:lstStyle/>
           <a:p>
             <a:pPr algn="ctr"/>
+            <a:endParaRPr/>
           </a:p>
         </p:txBody>
       </p:sp>
@@ -5894,6 +6766,7 @@
           <a:lstStyle/>
           <a:p>
             <a:pPr algn="ctr"/>
+            <a:endParaRPr/>
           </a:p>
         </p:txBody>
       </p:sp>
@@ -6005,6 +6878,7 @@
           <a:lstStyle/>
           <a:p>
             <a:pPr algn="ctr"/>
+            <a:endParaRPr/>
           </a:p>
         </p:txBody>
       </p:sp>
@@ -6116,6 +6990,7 @@
           <a:lstStyle/>
           <a:p>
             <a:pPr algn="ctr"/>
+            <a:endParaRPr/>
           </a:p>
         </p:txBody>
       </p:sp>
@@ -6227,6 +7102,7 @@
           <a:lstStyle/>
           <a:p>
             <a:pPr algn="ctr"/>
+            <a:endParaRPr/>
           </a:p>
         </p:txBody>
       </p:sp>
@@ -6338,6 +7214,7 @@
           <a:lstStyle/>
           <a:p>
             <a:pPr algn="ctr"/>
+            <a:endParaRPr/>
           </a:p>
         </p:txBody>
       </p:sp>
@@ -6449,6 +7326,7 @@
           <a:lstStyle/>
           <a:p>
             <a:pPr algn="ctr"/>
+            <a:endParaRPr/>
           </a:p>
         </p:txBody>
       </p:sp>
@@ -6560,6 +7438,7 @@
           <a:lstStyle/>
           <a:p>
             <a:pPr algn="ctr"/>
+            <a:endParaRPr/>
           </a:p>
         </p:txBody>
       </p:sp>
@@ -6640,7 +7519,7 @@
 </file>
 
 <file path=ppt/slides/slide5.xml><?xml version="1.0" encoding="utf-8"?>
-<p:sld xmlns:a="http://schemas.openxmlformats.org/drawingml/2006/main" xmlns:p="http://schemas.openxmlformats.org/presentationml/2006/main" xmlns:r="http://schemas.openxmlformats.org/officeDocument/2006/relationships">
+<p:sld xmlns:a="http://schemas.openxmlformats.org/drawingml/2006/main" xmlns:r="http://schemas.openxmlformats.org/officeDocument/2006/relationships" xmlns:p="http://schemas.openxmlformats.org/presentationml/2006/main">
   <p:cSld>
     <p:spTree>
       <p:nvGrpSpPr>
@@ -6648,7 +7527,14 @@
         <p:cNvGrpSpPr/>
         <p:nvPr/>
       </p:nvGrpSpPr>
-      <p:grpSpPr/>
+      <p:grpSpPr>
+        <a:xfrm>
+          <a:off x="0" y="0"/>
+          <a:ext cx="0" cy="0"/>
+          <a:chOff x="0" y="0"/>
+          <a:chExt cx="0" cy="0"/>
+        </a:xfrm>
+      </p:grpSpPr>
       <p:sp>
         <p:nvSpPr>
           <p:cNvPr id="2" name="Rectangle 1"/>
@@ -6689,6 +7575,7 @@
           <a:lstStyle/>
           <a:p>
             <a:pPr algn="ctr"/>
+            <a:endParaRPr/>
           </a:p>
         </p:txBody>
       </p:sp>
@@ -6732,6 +7619,7 @@
           <a:lstStyle/>
           <a:p>
             <a:pPr algn="ctr"/>
+            <a:endParaRPr/>
           </a:p>
         </p:txBody>
       </p:sp>
@@ -6809,6 +7697,7 @@
           <a:lstStyle/>
           <a:p>
             <a:pPr algn="ctr"/>
+            <a:endParaRPr/>
           </a:p>
         </p:txBody>
       </p:sp>
@@ -6852,6 +7741,7 @@
           <a:lstStyle/>
           <a:p>
             <a:pPr algn="ctr"/>
+            <a:endParaRPr/>
           </a:p>
         </p:txBody>
       </p:sp>
@@ -6910,7 +7800,9 @@
             <a:spAutoFit/>
           </a:bodyPr>
           <a:lstStyle/>
-          <a:p/>
+          <a:p>
+            <a:endParaRPr/>
+          </a:p>
           <a:p>
             <a:pPr algn="l">
               <a:spcBef>
@@ -7058,6 +7950,7 @@
           <a:lstStyle/>
           <a:p>
             <a:pPr algn="ctr"/>
+            <a:endParaRPr/>
           </a:p>
         </p:txBody>
       </p:sp>
@@ -7101,6 +7994,7 @@
           <a:lstStyle/>
           <a:p>
             <a:pPr algn="ctr"/>
+            <a:endParaRPr/>
           </a:p>
         </p:txBody>
       </p:sp>
@@ -7159,7 +8053,9 @@
             <a:spAutoFit/>
           </a:bodyPr>
           <a:lstStyle/>
-          <a:p/>
+          <a:p>
+            <a:endParaRPr/>
+          </a:p>
           <a:p>
             <a:pPr algn="l">
               <a:spcBef>
@@ -7276,7 +8172,7 @@
 </file>
 
 <file path=ppt/slides/slide6.xml><?xml version="1.0" encoding="utf-8"?>
-<p:sld xmlns:a="http://schemas.openxmlformats.org/drawingml/2006/main" xmlns:p="http://schemas.openxmlformats.org/presentationml/2006/main" xmlns:r="http://schemas.openxmlformats.org/officeDocument/2006/relationships">
+<p:sld xmlns:a="http://schemas.openxmlformats.org/drawingml/2006/main" xmlns:r="http://schemas.openxmlformats.org/officeDocument/2006/relationships" xmlns:p="http://schemas.openxmlformats.org/presentationml/2006/main">
   <p:cSld>
     <p:spTree>
       <p:nvGrpSpPr>
@@ -7284,7 +8180,14 @@
         <p:cNvGrpSpPr/>
         <p:nvPr/>
       </p:nvGrpSpPr>
-      <p:grpSpPr/>
+      <p:grpSpPr>
+        <a:xfrm>
+          <a:off x="0" y="0"/>
+          <a:ext cx="0" cy="0"/>
+          <a:chOff x="0" y="0"/>
+          <a:chExt cx="0" cy="0"/>
+        </a:xfrm>
+      </p:grpSpPr>
       <p:sp>
         <p:nvSpPr>
           <p:cNvPr id="2" name="Rectangle 1"/>
@@ -7325,6 +8228,7 @@
           <a:lstStyle/>
           <a:p>
             <a:pPr algn="ctr"/>
+            <a:endParaRPr/>
           </a:p>
         </p:txBody>
       </p:sp>
@@ -7368,6 +8272,7 @@
           <a:lstStyle/>
           <a:p>
             <a:pPr algn="ctr"/>
+            <a:endParaRPr/>
           </a:p>
         </p:txBody>
       </p:sp>
@@ -7445,6 +8350,7 @@
           <a:lstStyle/>
           <a:p>
             <a:pPr algn="ctr"/>
+            <a:endParaRPr/>
           </a:p>
         </p:txBody>
       </p:sp>
@@ -7488,6 +8394,7 @@
           <a:lstStyle/>
           <a:p>
             <a:pPr algn="ctr"/>
+            <a:endParaRPr/>
           </a:p>
         </p:txBody>
       </p:sp>
@@ -7546,7 +8453,9 @@
             <a:spAutoFit/>
           </a:bodyPr>
           <a:lstStyle/>
-          <a:p/>
+          <a:p>
+            <a:endParaRPr/>
+          </a:p>
           <a:p>
             <a:pPr algn="l">
               <a:spcBef>
@@ -7649,6 +8558,7 @@
           <a:lstStyle/>
           <a:p>
             <a:pPr algn="ctr"/>
+            <a:endParaRPr/>
           </a:p>
         </p:txBody>
       </p:sp>
@@ -7692,6 +8602,7 @@
           <a:lstStyle/>
           <a:p>
             <a:pPr algn="ctr"/>
+            <a:endParaRPr/>
           </a:p>
         </p:txBody>
       </p:sp>
@@ -7750,7 +8661,9 @@
             <a:spAutoFit/>
           </a:bodyPr>
           <a:lstStyle/>
-          <a:p/>
+          <a:p>
+            <a:endParaRPr/>
+          </a:p>
           <a:p>
             <a:pPr algn="l">
               <a:spcBef>
@@ -7853,6 +8766,7 @@
           <a:lstStyle/>
           <a:p>
             <a:pPr algn="ctr"/>
+            <a:endParaRPr/>
           </a:p>
         </p:txBody>
       </p:sp>
@@ -7896,6 +8810,7 @@
           <a:lstStyle/>
           <a:p>
             <a:pPr algn="ctr"/>
+            <a:endParaRPr/>
           </a:p>
         </p:txBody>
       </p:sp>
@@ -7954,7 +8869,9 @@
             <a:spAutoFit/>
           </a:bodyPr>
           <a:lstStyle/>
-          <a:p/>
+          <a:p>
+            <a:endParaRPr/>
+          </a:p>
           <a:p>
             <a:pPr algn="l">
               <a:spcBef>
@@ -8057,6 +8974,7 @@
           <a:lstStyle/>
           <a:p>
             <a:pPr algn="ctr"/>
+            <a:endParaRPr/>
           </a:p>
         </p:txBody>
       </p:sp>
@@ -8100,6 +9018,7 @@
           <a:lstStyle/>
           <a:p>
             <a:pPr algn="ctr"/>
+            <a:endParaRPr/>
           </a:p>
         </p:txBody>
       </p:sp>
@@ -8158,7 +9077,9 @@
             <a:spAutoFit/>
           </a:bodyPr>
           <a:lstStyle/>
-          <a:p/>
+          <a:p>
+            <a:endParaRPr/>
+          </a:p>
           <a:p>
             <a:pPr algn="l">
               <a:spcBef>
@@ -8230,7 +9151,7 @@
 </file>
 
 <file path=ppt/slides/slide7.xml><?xml version="1.0" encoding="utf-8"?>
-<p:sld xmlns:a="http://schemas.openxmlformats.org/drawingml/2006/main" xmlns:p="http://schemas.openxmlformats.org/presentationml/2006/main" xmlns:r="http://schemas.openxmlformats.org/officeDocument/2006/relationships">
+<p:sld xmlns:a="http://schemas.openxmlformats.org/drawingml/2006/main" xmlns:r="http://schemas.openxmlformats.org/officeDocument/2006/relationships" xmlns:p="http://schemas.openxmlformats.org/presentationml/2006/main">
   <p:cSld>
     <p:spTree>
       <p:nvGrpSpPr>
@@ -8238,7 +9159,14 @@
         <p:cNvGrpSpPr/>
         <p:nvPr/>
       </p:nvGrpSpPr>
-      <p:grpSpPr/>
+      <p:grpSpPr>
+        <a:xfrm>
+          <a:off x="0" y="0"/>
+          <a:ext cx="0" cy="0"/>
+          <a:chOff x="0" y="0"/>
+          <a:chExt cx="0" cy="0"/>
+        </a:xfrm>
+      </p:grpSpPr>
       <p:sp>
         <p:nvSpPr>
           <p:cNvPr id="2" name="Rectangle 1"/>
@@ -8279,6 +9207,7 @@
           <a:lstStyle/>
           <a:p>
             <a:pPr algn="ctr"/>
+            <a:endParaRPr/>
           </a:p>
         </p:txBody>
       </p:sp>
@@ -8322,6 +9251,7 @@
           <a:lstStyle/>
           <a:p>
             <a:pPr algn="ctr"/>
+            <a:endParaRPr/>
           </a:p>
         </p:txBody>
       </p:sp>
@@ -8457,6 +9387,7 @@
           <a:lstStyle/>
           <a:p>
             <a:pPr algn="ctr"/>
+            <a:endParaRPr/>
           </a:p>
         </p:txBody>
       </p:sp>
@@ -8481,7 +9412,9 @@
             <a:spAutoFit/>
           </a:bodyPr>
           <a:lstStyle/>
-          <a:p/>
+          <a:p>
+            <a:endParaRPr/>
+          </a:p>
           <a:p>
             <a:pPr>
               <a:spcBef>
@@ -8496,14 +9429,6 @@
               </a:rPr>
               <a:t>Presentatielaag</a:t>
             </a:r>
-            <a:r>
-              <a:rPr sz="1100">
-                <a:solidFill>
-                  <a:srgbClr val="D0D8E8"/>
-                </a:solidFill>
-              </a:rPr>
-              <a:t/>
-            </a:r>
           </a:p>
           <a:p>
             <a:pPr>
@@ -8519,14 +9444,6 @@
               </a:rPr>
               <a:t>Flask Blueprints · Jinja2-templates · Bootstrap 5</a:t>
             </a:r>
-            <a:r>
-              <a:rPr sz="1100">
-                <a:solidFill>
-                  <a:srgbClr val="D0D8E8"/>
-                </a:solidFill>
-              </a:rPr>
-              <a:t/>
-            </a:r>
           </a:p>
           <a:p>
             <a:pPr>
@@ -8542,14 +9459,6 @@
               </a:rPr>
               <a:t>Bedrijfslaag</a:t>
             </a:r>
-            <a:r>
-              <a:rPr sz="1100">
-                <a:solidFill>
-                  <a:srgbClr val="D0D8E8"/>
-                </a:solidFill>
-              </a:rPr>
-              <a:t/>
-            </a:r>
           </a:p>
           <a:p>
             <a:pPr>
@@ -8565,14 +9474,6 @@
               </a:rPr>
               <a:t>InterlockService · FaultCountService</a:t>
             </a:r>
-            <a:r>
-              <a:rPr sz="1100">
-                <a:solidFill>
-                  <a:srgbClr val="D0D8E8"/>
-                </a:solidFill>
-              </a:rPr>
-              <a:t/>
-            </a:r>
           </a:p>
           <a:p>
             <a:pPr>
@@ -8588,14 +9489,6 @@
               </a:rPr>
               <a:t>Datalaag</a:t>
             </a:r>
-            <a:r>
-              <a:rPr sz="1100">
-                <a:solidFill>
-                  <a:srgbClr val="D0D8E8"/>
-                </a:solidFill>
-              </a:rPr>
-              <a:t/>
-            </a:r>
           </a:p>
           <a:p>
             <a:pPr>
@@ -8611,14 +9504,6 @@
               </a:rPr>
               <a:t>SQLAlchemy ORM · SnapshotRepository · DB_Connection</a:t>
             </a:r>
-            <a:r>
-              <a:rPr sz="1100">
-                <a:solidFill>
-                  <a:srgbClr val="D0D8E8"/>
-                </a:solidFill>
-              </a:rPr>
-              <a:t/>
-            </a:r>
           </a:p>
           <a:p>
             <a:pPr>
@@ -8633,14 +9518,6 @@
                 </a:solidFill>
               </a:rPr>
               <a:t>Database</a:t>
-            </a:r>
-            <a:r>
-              <a:rPr sz="1100">
-                <a:solidFill>
-                  <a:srgbClr val="D0D8E8"/>
-                </a:solidFill>
-              </a:rPr>
-              <a:t/>
             </a:r>
           </a:p>
         </p:txBody>
@@ -8688,7 +9565,7 @@
 </file>
 
 <file path=ppt/slides/slide8.xml><?xml version="1.0" encoding="utf-8"?>
-<p:sld xmlns:a="http://schemas.openxmlformats.org/drawingml/2006/main" xmlns:p="http://schemas.openxmlformats.org/presentationml/2006/main" xmlns:r="http://schemas.openxmlformats.org/officeDocument/2006/relationships">
+<p:sld xmlns:a="http://schemas.openxmlformats.org/drawingml/2006/main" xmlns:r="http://schemas.openxmlformats.org/officeDocument/2006/relationships" xmlns:p="http://schemas.openxmlformats.org/presentationml/2006/main">
   <p:cSld>
     <p:spTree>
       <p:nvGrpSpPr>
@@ -8696,7 +9573,14 @@
         <p:cNvGrpSpPr/>
         <p:nvPr/>
       </p:nvGrpSpPr>
-      <p:grpSpPr/>
+      <p:grpSpPr>
+        <a:xfrm>
+          <a:off x="0" y="0"/>
+          <a:ext cx="0" cy="0"/>
+          <a:chOff x="0" y="0"/>
+          <a:chExt cx="0" cy="0"/>
+        </a:xfrm>
+      </p:grpSpPr>
       <p:sp>
         <p:nvSpPr>
           <p:cNvPr id="2" name="Rectangle 1"/>
@@ -8737,6 +9621,7 @@
           <a:lstStyle/>
           <a:p>
             <a:pPr algn="ctr"/>
+            <a:endParaRPr/>
           </a:p>
         </p:txBody>
       </p:sp>
@@ -8780,6 +9665,7 @@
           <a:lstStyle/>
           <a:p>
             <a:pPr algn="ctr"/>
+            <a:endParaRPr/>
           </a:p>
         </p:txBody>
       </p:sp>
@@ -8891,6 +9777,7 @@
           <a:lstStyle/>
           <a:p>
             <a:pPr algn="ctr"/>
+            <a:endParaRPr/>
           </a:p>
         </p:txBody>
       </p:sp>
@@ -8934,6 +9821,7 @@
           <a:lstStyle/>
           <a:p>
             <a:pPr algn="ctr"/>
+            <a:endParaRPr/>
           </a:p>
         </p:txBody>
       </p:sp>
@@ -9026,7 +9914,9 @@
             <a:spAutoFit/>
           </a:bodyPr>
           <a:lstStyle/>
-          <a:p/>
+          <a:p>
+            <a:endParaRPr/>
+          </a:p>
           <a:p>
             <a:pPr algn="l">
               <a:spcBef>
@@ -9189,6 +10079,7 @@
           <a:lstStyle/>
           <a:p>
             <a:pPr algn="ctr"/>
+            <a:endParaRPr/>
           </a:p>
         </p:txBody>
       </p:sp>
@@ -9232,6 +10123,7 @@
           <a:lstStyle/>
           <a:p>
             <a:pPr algn="ctr"/>
+            <a:endParaRPr/>
           </a:p>
         </p:txBody>
       </p:sp>
@@ -9324,7 +10216,9 @@
             <a:spAutoFit/>
           </a:bodyPr>
           <a:lstStyle/>
-          <a:p/>
+          <a:p>
+            <a:endParaRPr/>
+          </a:p>
           <a:p>
             <a:pPr algn="l">
               <a:spcBef>
@@ -9442,6 +10336,7 @@
           <a:lstStyle/>
           <a:p>
             <a:pPr algn="ctr"/>
+            <a:endParaRPr/>
           </a:p>
         </p:txBody>
       </p:sp>
@@ -9485,6 +10380,7 @@
           <a:lstStyle/>
           <a:p>
             <a:pPr algn="ctr"/>
+            <a:endParaRPr/>
           </a:p>
         </p:txBody>
       </p:sp>
@@ -9577,7 +10473,9 @@
             <a:spAutoFit/>
           </a:bodyPr>
           <a:lstStyle/>
-          <a:p/>
+          <a:p>
+            <a:endParaRPr/>
+          </a:p>
           <a:p>
             <a:pPr algn="l">
               <a:spcBef>
@@ -9680,6 +10578,7 @@
           <a:lstStyle/>
           <a:p>
             <a:pPr algn="ctr"/>
+            <a:endParaRPr/>
           </a:p>
         </p:txBody>
       </p:sp>
@@ -9723,6 +10622,7 @@
           <a:lstStyle/>
           <a:p>
             <a:pPr algn="ctr"/>
+            <a:endParaRPr/>
           </a:p>
         </p:txBody>
       </p:sp>
@@ -9815,7 +10715,9 @@
             <a:spAutoFit/>
           </a:bodyPr>
           <a:lstStyle/>
-          <a:p/>
+          <a:p>
+            <a:endParaRPr/>
+          </a:p>
           <a:p>
             <a:pPr algn="l">
               <a:spcBef>
@@ -9887,7 +10789,7 @@
 </file>
 
 <file path=ppt/slides/slide9.xml><?xml version="1.0" encoding="utf-8"?>
-<p:sld xmlns:a="http://schemas.openxmlformats.org/drawingml/2006/main" xmlns:p="http://schemas.openxmlformats.org/presentationml/2006/main" xmlns:r="http://schemas.openxmlformats.org/officeDocument/2006/relationships">
+<p:sld xmlns:a="http://schemas.openxmlformats.org/drawingml/2006/main" xmlns:r="http://schemas.openxmlformats.org/officeDocument/2006/relationships" xmlns:p="http://schemas.openxmlformats.org/presentationml/2006/main">
   <p:cSld>
     <p:spTree>
       <p:nvGrpSpPr>
@@ -9895,7 +10797,14 @@
         <p:cNvGrpSpPr/>
         <p:nvPr/>
       </p:nvGrpSpPr>
-      <p:grpSpPr/>
+      <p:grpSpPr>
+        <a:xfrm>
+          <a:off x="0" y="0"/>
+          <a:ext cx="0" cy="0"/>
+          <a:chOff x="0" y="0"/>
+          <a:chExt cx="0" cy="0"/>
+        </a:xfrm>
+      </p:grpSpPr>
       <p:sp>
         <p:nvSpPr>
           <p:cNvPr id="2" name="Rectangle 1"/>
@@ -9936,6 +10845,7 @@
           <a:lstStyle/>
           <a:p>
             <a:pPr algn="ctr"/>
+            <a:endParaRPr/>
           </a:p>
         </p:txBody>
       </p:sp>
@@ -9979,6 +10889,7 @@
           <a:lstStyle/>
           <a:p>
             <a:pPr algn="ctr"/>
+            <a:endParaRPr/>
           </a:p>
         </p:txBody>
       </p:sp>
@@ -10090,6 +11001,7 @@
           <a:lstStyle/>
           <a:p>
             <a:pPr algn="ctr"/>
+            <a:endParaRPr/>
           </a:p>
         </p:txBody>
       </p:sp>
@@ -10167,6 +11079,7 @@
           <a:lstStyle/>
           <a:p>
             <a:pPr algn="ctr"/>
+            <a:endParaRPr/>
           </a:p>
         </p:txBody>
       </p:sp>
@@ -10210,6 +11123,7 @@
           <a:lstStyle/>
           <a:p>
             <a:pPr algn="ctr"/>
+            <a:endParaRPr/>
           </a:p>
         </p:txBody>
       </p:sp>
@@ -10321,6 +11235,7 @@
           <a:lstStyle/>
           <a:p>
             <a:pPr algn="ctr"/>
+            <a:endParaRPr/>
           </a:p>
         </p:txBody>
       </p:sp>
@@ -10398,6 +11313,7 @@
           <a:lstStyle/>
           <a:p>
             <a:pPr algn="ctr"/>
+            <a:endParaRPr/>
           </a:p>
         </p:txBody>
       </p:sp>
@@ -10441,6 +11357,7 @@
           <a:lstStyle/>
           <a:p>
             <a:pPr algn="ctr"/>
+            <a:endParaRPr/>
           </a:p>
         </p:txBody>
       </p:sp>
@@ -10552,6 +11469,7 @@
           <a:lstStyle/>
           <a:p>
             <a:pPr algn="ctr"/>
+            <a:endParaRPr/>
           </a:p>
         </p:txBody>
       </p:sp>
@@ -10629,6 +11547,7 @@
           <a:lstStyle/>
           <a:p>
             <a:pPr algn="ctr"/>
+            <a:endParaRPr/>
           </a:p>
         </p:txBody>
       </p:sp>
@@ -10672,6 +11591,7 @@
           <a:lstStyle/>
           <a:p>
             <a:pPr algn="ctr"/>
+            <a:endParaRPr/>
           </a:p>
         </p:txBody>
       </p:sp>
@@ -10783,6 +11703,7 @@
           <a:lstStyle/>
           <a:p>
             <a:pPr algn="ctr"/>
+            <a:endParaRPr/>
           </a:p>
         </p:txBody>
       </p:sp>
@@ -10860,6 +11781,7 @@
           <a:lstStyle/>
           <a:p>
             <a:pPr algn="ctr"/>
+            <a:endParaRPr/>
           </a:p>
         </p:txBody>
       </p:sp>
@@ -10903,6 +11825,7 @@
           <a:lstStyle/>
           <a:p>
             <a:pPr algn="ctr"/>
+            <a:endParaRPr/>
           </a:p>
         </p:txBody>
       </p:sp>
@@ -11014,6 +11937,7 @@
           <a:lstStyle/>
           <a:p>
             <a:pPr algn="ctr"/>
+            <a:endParaRPr/>
           </a:p>
         </p:txBody>
       </p:sp>
@@ -11091,6 +12015,7 @@
           <a:lstStyle/>
           <a:p>
             <a:pPr algn="ctr"/>
+            <a:endParaRPr/>
           </a:p>
         </p:txBody>
       </p:sp>
@@ -11134,6 +12059,7 @@
           <a:lstStyle/>
           <a:p>
             <a:pPr algn="ctr"/>
+            <a:endParaRPr/>
           </a:p>
         </p:txBody>
       </p:sp>
@@ -11531,4 +12457,319 @@
   </a:objectDefaults>
   <a:extraClrSchemeLst/>
 </a:theme>
+</file>
+
+<file path=ppt/theme/theme2.xml><?xml version="1.0" encoding="utf-8"?>
+<a:theme xmlns:a="http://schemas.openxmlformats.org/drawingml/2006/main" name="Kantoorthema">
+  <a:themeElements>
+    <a:clrScheme name="Office">
+      <a:dk1>
+        <a:sysClr val="windowText" lastClr="000000"/>
+      </a:dk1>
+      <a:lt1>
+        <a:sysClr val="window" lastClr="FFFFFF"/>
+      </a:lt1>
+      <a:dk2>
+        <a:srgbClr val="0E2841"/>
+      </a:dk2>
+      <a:lt2>
+        <a:srgbClr val="E8E8E8"/>
+      </a:lt2>
+      <a:accent1>
+        <a:srgbClr val="156082"/>
+      </a:accent1>
+      <a:accent2>
+        <a:srgbClr val="E97132"/>
+      </a:accent2>
+      <a:accent3>
+        <a:srgbClr val="196B24"/>
+      </a:accent3>
+      <a:accent4>
+        <a:srgbClr val="0F9ED5"/>
+      </a:accent4>
+      <a:accent5>
+        <a:srgbClr val="A02B93"/>
+      </a:accent5>
+      <a:accent6>
+        <a:srgbClr val="4EA72E"/>
+      </a:accent6>
+      <a:hlink>
+        <a:srgbClr val="467886"/>
+      </a:hlink>
+      <a:folHlink>
+        <a:srgbClr val="96607D"/>
+      </a:folHlink>
+    </a:clrScheme>
+    <a:fontScheme name="Office">
+      <a:majorFont>
+        <a:latin typeface="Aptos Display" panose="02110004020202020204"/>
+        <a:ea typeface=""/>
+        <a:cs typeface=""/>
+        <a:font script="Jpan" typeface="游ゴシック Light"/>
+        <a:font script="Hang" typeface="맑은 고딕"/>
+        <a:font script="Hans" typeface="等线 Light"/>
+        <a:font script="Hant" typeface="新細明體"/>
+        <a:font script="Arab" typeface="Times New Roman"/>
+        <a:font script="Hebr" typeface="Times New Roman"/>
+        <a:font script="Thai" typeface="Angsana New"/>
+        <a:font script="Ethi" typeface="Nyala"/>
+        <a:font script="Beng" typeface="Vrinda"/>
+        <a:font script="Gujr" typeface="Shruti"/>
+        <a:font script="Khmr" typeface="MoolBoran"/>
+        <a:font script="Knda" typeface="Tunga"/>
+        <a:font script="Guru" typeface="Raavi"/>
+        <a:font script="Cans" typeface="Euphemia"/>
+        <a:font script="Cher" typeface="Plantagenet Cherokee"/>
+        <a:font script="Yiii" typeface="Microsoft Yi Baiti"/>
+        <a:font script="Tibt" typeface="Microsoft Himalaya"/>
+        <a:font script="Thaa" typeface="MV Boli"/>
+        <a:font script="Deva" typeface="Mangal"/>
+        <a:font script="Telu" typeface="Gautami"/>
+        <a:font script="Taml" typeface="Latha"/>
+        <a:font script="Syrc" typeface="Estrangelo Edessa"/>
+        <a:font script="Orya" typeface="Kalinga"/>
+        <a:font script="Mlym" typeface="Kartika"/>
+        <a:font script="Laoo" typeface="DokChampa"/>
+        <a:font script="Sinh" typeface="Iskoola Pota"/>
+        <a:font script="Mong" typeface="Mongolian Baiti"/>
+        <a:font script="Viet" typeface="Times New Roman"/>
+        <a:font script="Uigh" typeface="Microsoft Uighur"/>
+        <a:font script="Geor" typeface="Sylfaen"/>
+        <a:font script="Armn" typeface="Arial"/>
+        <a:font script="Bugi" typeface="Leelawadee UI"/>
+        <a:font script="Bopo" typeface="Microsoft JhengHei"/>
+        <a:font script="Java" typeface="Javanese Text"/>
+        <a:font script="Lisu" typeface="Segoe UI"/>
+        <a:font script="Mymr" typeface="Myanmar Text"/>
+        <a:font script="Nkoo" typeface="Ebrima"/>
+        <a:font script="Olck" typeface="Nirmala UI"/>
+        <a:font script="Osma" typeface="Ebrima"/>
+        <a:font script="Phag" typeface="Phagspa"/>
+        <a:font script="Syrn" typeface="Estrangelo Edessa"/>
+        <a:font script="Syrj" typeface="Estrangelo Edessa"/>
+        <a:font script="Syre" typeface="Estrangelo Edessa"/>
+        <a:font script="Sora" typeface="Nirmala UI"/>
+        <a:font script="Tale" typeface="Microsoft Tai Le"/>
+        <a:font script="Talu" typeface="Microsoft New Tai Lue"/>
+        <a:font script="Tfng" typeface="Ebrima"/>
+      </a:majorFont>
+      <a:minorFont>
+        <a:latin typeface="Aptos" panose="02110004020202020204"/>
+        <a:ea typeface=""/>
+        <a:cs typeface=""/>
+        <a:font script="Jpan" typeface="游ゴシック"/>
+        <a:font script="Hang" typeface="맑은 고딕"/>
+        <a:font script="Hans" typeface="等线"/>
+        <a:font script="Hant" typeface="新細明體"/>
+        <a:font script="Arab" typeface="Arial"/>
+        <a:font script="Hebr" typeface="Arial"/>
+        <a:font script="Thai" typeface="Cordia New"/>
+        <a:font script="Ethi" typeface="Nyala"/>
+        <a:font script="Beng" typeface="Vrinda"/>
+        <a:font script="Gujr" typeface="Shruti"/>
+        <a:font script="Khmr" typeface="DaunPenh"/>
+        <a:font script="Knda" typeface="Tunga"/>
+        <a:font script="Guru" typeface="Raavi"/>
+        <a:font script="Cans" typeface="Euphemia"/>
+        <a:font script="Cher" typeface="Plantagenet Cherokee"/>
+        <a:font script="Yiii" typeface="Microsoft Yi Baiti"/>
+        <a:font script="Tibt" typeface="Microsoft Himalaya"/>
+        <a:font script="Thaa" typeface="MV Boli"/>
+        <a:font script="Deva" typeface="Mangal"/>
+        <a:font script="Telu" typeface="Gautami"/>
+        <a:font script="Taml" typeface="Latha"/>
+        <a:font script="Syrc" typeface="Estrangelo Edessa"/>
+        <a:font script="Orya" typeface="Kalinga"/>
+        <a:font script="Mlym" typeface="Kartika"/>
+        <a:font script="Laoo" typeface="DokChampa"/>
+        <a:font script="Sinh" typeface="Iskoola Pota"/>
+        <a:font script="Mong" typeface="Mongolian Baiti"/>
+        <a:font script="Viet" typeface="Arial"/>
+        <a:font script="Uigh" typeface="Microsoft Uighur"/>
+        <a:font script="Geor" typeface="Sylfaen"/>
+        <a:font script="Armn" typeface="Arial"/>
+        <a:font script="Bugi" typeface="Leelawadee UI"/>
+        <a:font script="Bopo" typeface="Microsoft JhengHei"/>
+        <a:font script="Java" typeface="Javanese Text"/>
+        <a:font script="Lisu" typeface="Segoe UI"/>
+        <a:font script="Mymr" typeface="Myanmar Text"/>
+        <a:font script="Nkoo" typeface="Ebrima"/>
+        <a:font script="Olck" typeface="Nirmala UI"/>
+        <a:font script="Osma" typeface="Ebrima"/>
+        <a:font script="Phag" typeface="Phagspa"/>
+        <a:font script="Syrn" typeface="Estrangelo Edessa"/>
+        <a:font script="Syrj" typeface="Estrangelo Edessa"/>
+        <a:font script="Syre" typeface="Estrangelo Edessa"/>
+        <a:font script="Sora" typeface="Nirmala UI"/>
+        <a:font script="Tale" typeface="Microsoft Tai Le"/>
+        <a:font script="Talu" typeface="Microsoft New Tai Lue"/>
+        <a:font script="Tfng" typeface="Ebrima"/>
+      </a:minorFont>
+    </a:fontScheme>
+    <a:fmtScheme name="Office">
+      <a:fillStyleLst>
+        <a:solidFill>
+          <a:schemeClr val="phClr"/>
+        </a:solidFill>
+        <a:gradFill rotWithShape="1">
+          <a:gsLst>
+            <a:gs pos="0">
+              <a:schemeClr val="phClr">
+                <a:lumMod val="110000"/>
+                <a:satMod val="105000"/>
+                <a:tint val="67000"/>
+              </a:schemeClr>
+            </a:gs>
+            <a:gs pos="50000">
+              <a:schemeClr val="phClr">
+                <a:lumMod val="105000"/>
+                <a:satMod val="103000"/>
+                <a:tint val="73000"/>
+              </a:schemeClr>
+            </a:gs>
+            <a:gs pos="100000">
+              <a:schemeClr val="phClr">
+                <a:lumMod val="105000"/>
+                <a:satMod val="109000"/>
+                <a:tint val="81000"/>
+              </a:schemeClr>
+            </a:gs>
+          </a:gsLst>
+          <a:lin ang="5400000" scaled="0"/>
+        </a:gradFill>
+        <a:gradFill rotWithShape="1">
+          <a:gsLst>
+            <a:gs pos="0">
+              <a:schemeClr val="phClr">
+                <a:satMod val="103000"/>
+                <a:lumMod val="102000"/>
+                <a:tint val="94000"/>
+              </a:schemeClr>
+            </a:gs>
+            <a:gs pos="50000">
+              <a:schemeClr val="phClr">
+                <a:satMod val="110000"/>
+                <a:lumMod val="100000"/>
+                <a:shade val="100000"/>
+              </a:schemeClr>
+            </a:gs>
+            <a:gs pos="100000">
+              <a:schemeClr val="phClr">
+                <a:lumMod val="99000"/>
+                <a:satMod val="120000"/>
+                <a:shade val="78000"/>
+              </a:schemeClr>
+            </a:gs>
+          </a:gsLst>
+          <a:lin ang="5400000" scaled="0"/>
+        </a:gradFill>
+      </a:fillStyleLst>
+      <a:lnStyleLst>
+        <a:ln w="12700" cap="flat" cmpd="sng" algn="ctr">
+          <a:solidFill>
+            <a:schemeClr val="phClr"/>
+          </a:solidFill>
+          <a:prstDash val="solid"/>
+          <a:miter lim="800000"/>
+        </a:ln>
+        <a:ln w="19050" cap="flat" cmpd="sng" algn="ctr">
+          <a:solidFill>
+            <a:schemeClr val="phClr"/>
+          </a:solidFill>
+          <a:prstDash val="solid"/>
+          <a:miter lim="800000"/>
+        </a:ln>
+        <a:ln w="25400" cap="flat" cmpd="sng" algn="ctr">
+          <a:solidFill>
+            <a:schemeClr val="phClr"/>
+          </a:solidFill>
+          <a:prstDash val="solid"/>
+          <a:miter lim="800000"/>
+        </a:ln>
+      </a:lnStyleLst>
+      <a:effectStyleLst>
+        <a:effectStyle>
+          <a:effectLst/>
+        </a:effectStyle>
+        <a:effectStyle>
+          <a:effectLst/>
+        </a:effectStyle>
+        <a:effectStyle>
+          <a:effectLst>
+            <a:outerShdw blurRad="57150" dist="19050" dir="5400000" algn="ctr" rotWithShape="0">
+              <a:srgbClr val="000000">
+                <a:alpha val="63000"/>
+              </a:srgbClr>
+            </a:outerShdw>
+          </a:effectLst>
+        </a:effectStyle>
+      </a:effectStyleLst>
+      <a:bgFillStyleLst>
+        <a:solidFill>
+          <a:schemeClr val="phClr"/>
+        </a:solidFill>
+        <a:solidFill>
+          <a:schemeClr val="phClr">
+            <a:tint val="95000"/>
+            <a:satMod val="170000"/>
+          </a:schemeClr>
+        </a:solidFill>
+        <a:gradFill rotWithShape="1">
+          <a:gsLst>
+            <a:gs pos="0">
+              <a:schemeClr val="phClr">
+                <a:tint val="93000"/>
+                <a:satMod val="150000"/>
+                <a:shade val="98000"/>
+                <a:lumMod val="102000"/>
+              </a:schemeClr>
+            </a:gs>
+            <a:gs pos="50000">
+              <a:schemeClr val="phClr">
+                <a:tint val="98000"/>
+                <a:satMod val="130000"/>
+                <a:shade val="90000"/>
+                <a:lumMod val="103000"/>
+              </a:schemeClr>
+            </a:gs>
+            <a:gs pos="100000">
+              <a:schemeClr val="phClr">
+                <a:shade val="63000"/>
+                <a:satMod val="120000"/>
+              </a:schemeClr>
+            </a:gs>
+          </a:gsLst>
+          <a:lin ang="5400000" scaled="0"/>
+        </a:gradFill>
+      </a:bgFillStyleLst>
+    </a:fmtScheme>
+  </a:themeElements>
+  <a:objectDefaults>
+    <a:lnDef>
+      <a:spPr/>
+      <a:bodyPr/>
+      <a:lstStyle/>
+      <a:style>
+        <a:lnRef idx="2">
+          <a:schemeClr val="accent1"/>
+        </a:lnRef>
+        <a:fillRef idx="0">
+          <a:schemeClr val="accent1"/>
+        </a:fillRef>
+        <a:effectRef idx="1">
+          <a:schemeClr val="accent1"/>
+        </a:effectRef>
+        <a:fontRef idx="minor">
+          <a:schemeClr val="tx1"/>
+        </a:fontRef>
+      </a:style>
+    </a:lnDef>
+  </a:objectDefaults>
+  <a:extraClrSchemeLst/>
+  <a:extLst>
+    <a:ext uri="{05A4C25C-085E-4340-85A3-A5531E510DB2}">
+      <thm15:themeFamily xmlns:thm15="http://schemas.microsoft.com/office/thememl/2012/main" name="Office Theme" id="{2E142A2C-CD16-42D6-873A-C26D2A0506FA}" vid="{1BDDFF52-6CD6-40A5-AB3C-68EB2F1E4D0A}"/>
+    </a:ext>
+  </a:extLst>
+</a:theme>
 </file>
</xml_diff>